<commit_message>
Validate portal release and refresh sync workflow
</commit_message>
<xml_diff>
--- a/exports/Moradabad_Division_DRM_Budget_FR_Analysis.pptx
+++ b/exports/Moradabad_Division_DRM_Budget_FR_Analysis.pptx
@@ -6251,10 +6251,10 @@
                 <a:gridCol w="1118625"/>
                 <a:gridCol w="1118625"/>
                 <a:gridCol w="1222201"/>
-                <a:gridCol w="745749"/>
+                <a:gridCol w="745750"/>
                 <a:gridCol w="1222201"/>
-                <a:gridCol w="745749"/>
-                <a:gridCol w="1118629"/>
+                <a:gridCol w="745750"/>
+                <a:gridCol w="1118627"/>
               </a:tblGrid>
               <a:tr h="432714">
                 <a:tc>

</xml_diff>

<commit_message>
new updates with 25
</commit_message>
<xml_diff>
--- a/exports/Moradabad_Division_DRM_Budget_FR_Analysis.pptx
+++ b/exports/Moradabad_Division_DRM_Budget_FR_Analysis.pptx
@@ -6185,7 +6185,7 @@
                 </a:solidFill>
                 <a:latin typeface="Times New Roman"/>
               </a:rPr>
-              <a:t>Demand SMH Wise - AUG 2026 | uploaded 2026-09-22T17:27:48+05:30</a:t>
+              <a:t>Demand SMH Wise - AUG 2026 | uploaded 2026-09-25T10:56:20+05:30</a:t>
             </a:r>
           </a:p>
         </p:txBody>
@@ -13284,7 +13284,7 @@
                 </a:solidFill>
                 <a:latin typeface="Times New Roman"/>
               </a:rPr>
-              <a:t>PU Wise - Staff - AUG 2026 | uploaded 2026-09-22T17:27:48+05:30</a:t>
+              <a:t>PU Wise - Staff - AUG 2026 | uploaded 2026-09-25T10:56:20+05:30</a:t>
             </a:r>
           </a:p>
         </p:txBody>
@@ -13940,7 +13940,7 @@
                           </a:solidFill>
                           <a:latin typeface="Times New Roman"/>
                         </a:rPr>
-                        <a:t>671</a:t>
+                        <a:t>6,706,409</a:t>
                       </a:r>
                       <a:br/>
                       <a:r>
@@ -13950,7 +13950,7 @@
                           </a:solidFill>
                           <a:latin typeface="Times New Roman"/>
                         </a:rPr>
-                        <a:t>0.07 Cr</a:t>
+                        <a:t>670.64 Cr</a:t>
                       </a:r>
                     </a:p>
                   </a:txBody>
@@ -13993,7 +13993,7 @@
                           </a:solidFill>
                           <a:latin typeface="Times New Roman"/>
                         </a:rPr>
-                        <a:t>280</a:t>
+                        <a:t>2,794,337</a:t>
                       </a:r>
                       <a:br/>
                       <a:r>
@@ -14003,7 +14003,7 @@
                           </a:solidFill>
                           <a:latin typeface="Times New Roman"/>
                         </a:rPr>
-                        <a:t>0.03 Cr</a:t>
+                        <a:t>279.43 Cr</a:t>
                       </a:r>
                     </a:p>
                   </a:txBody>
@@ -14099,7 +14099,7 @@
                           </a:solidFill>
                           <a:latin typeface="Times New Roman"/>
                         </a:rPr>
-                        <a:t>3,071,543</a:t>
+                        <a:t>277,486</a:t>
                       </a:r>
                       <a:br/>
                       <a:r>
@@ -14109,7 +14109,7 @@
                           </a:solidFill>
                           <a:latin typeface="Times New Roman"/>
                         </a:rPr>
-                        <a:t>307.15 Cr</a:t>
+                        <a:t>27.75 Cr</a:t>
                       </a:r>
                     </a:p>
                   </a:txBody>
@@ -14152,7 +14152,7 @@
                           </a:solidFill>
                           <a:latin typeface="Times New Roman"/>
                         </a:rPr>
-                        <a:t>1098715</a:t>
+                        <a:t>110</a:t>
                       </a:r>
                     </a:p>
                   </a:txBody>
@@ -14195,7 +14195,7 @@
                           </a:solidFill>
                           <a:latin typeface="Times New Roman"/>
                         </a:rPr>
-                        <a:t>-3,071,152</a:t>
+                        <a:t>3,634,586</a:t>
                       </a:r>
                       <a:br/>
                       <a:r>
@@ -14205,7 +14205,7 @@
                           </a:solidFill>
                           <a:latin typeface="Times New Roman"/>
                         </a:rPr>
-                        <a:t>-307.12 Cr</a:t>
+                        <a:t>363.46 Cr</a:t>
                       </a:r>
                     </a:p>
                   </a:txBody>
@@ -14248,33 +14248,33 @@
                           </a:solidFill>
                           <a:latin typeface="Times New Roman"/>
                         </a:rPr>
-                        <a:t>457798</a:t>
-                      </a:r>
-                    </a:p>
-                  </a:txBody>
-                  <a:tcPr marL="12000" marR="12000" marT="8000" marB="8000">
-                    <a:lnL w="12700">
-                      <a:solidFill>
-                        <a:srgbClr val="000000"/>
-                      </a:solidFill>
-                    </a:lnL>
-                    <a:lnR w="12700">
-                      <a:solidFill>
-                        <a:srgbClr val="000000"/>
-                      </a:solidFill>
-                    </a:lnR>
-                    <a:lnT w="12700">
-                      <a:solidFill>
-                        <a:srgbClr val="000000"/>
-                      </a:solidFill>
-                    </a:lnT>
-                    <a:lnB w="12700">
-                      <a:solidFill>
-                        <a:srgbClr val="000000"/>
-                      </a:solidFill>
-                    </a:lnB>
-                    <a:solidFill>
-                      <a:srgbClr val="FCE4E4"/>
+                        <a:t>46</a:t>
+                      </a:r>
+                    </a:p>
+                  </a:txBody>
+                  <a:tcPr marL="12000" marR="12000" marT="8000" marB="8000">
+                    <a:lnL w="12700">
+                      <a:solidFill>
+                        <a:srgbClr val="000000"/>
+                      </a:solidFill>
+                    </a:lnL>
+                    <a:lnR w="12700">
+                      <a:solidFill>
+                        <a:srgbClr val="000000"/>
+                      </a:solidFill>
+                    </a:lnR>
+                    <a:lnT w="12700">
+                      <a:solidFill>
+                        <a:srgbClr val="000000"/>
+                      </a:solidFill>
+                    </a:lnT>
+                    <a:lnB w="12700">
+                      <a:solidFill>
+                        <a:srgbClr val="000000"/>
+                      </a:solidFill>
+                    </a:lnB>
+                    <a:solidFill>
+                      <a:srgbClr val="DFF3E7"/>
                     </a:solidFill>
                   </a:tcPr>
                 </a:tc>
@@ -14389,7 +14389,7 @@
                           </a:solidFill>
                           <a:latin typeface="Times New Roman"/>
                         </a:rPr>
-                        <a:t>410</a:t>
+                        <a:t>4,100,453</a:t>
                       </a:r>
                       <a:br/>
                       <a:r>
@@ -14399,7 +14399,7 @@
                           </a:solidFill>
                           <a:latin typeface="Times New Roman"/>
                         </a:rPr>
-                        <a:t>0.04 Cr</a:t>
+                        <a:t>410.05 Cr</a:t>
                       </a:r>
                     </a:p>
                   </a:txBody>
@@ -14442,7 +14442,7 @@
                           </a:solidFill>
                           <a:latin typeface="Times New Roman"/>
                         </a:rPr>
-                        <a:t>171</a:t>
+                        <a:t>1,708,522</a:t>
                       </a:r>
                       <a:br/>
                       <a:r>
@@ -14452,7 +14452,7 @@
                           </a:solidFill>
                           <a:latin typeface="Times New Roman"/>
                         </a:rPr>
-                        <a:t>0.02 Cr</a:t>
+                        <a:t>170.85 Cr</a:t>
                       </a:r>
                     </a:p>
                   </a:txBody>
@@ -14548,7 +14548,7 @@
                           </a:solidFill>
                           <a:latin typeface="Times New Roman"/>
                         </a:rPr>
-                        <a:t>1,966,447</a:t>
+                        <a:t>258,096</a:t>
                       </a:r>
                       <a:br/>
                       <a:r>
@@ -14558,7 +14558,7 @@
                           </a:solidFill>
                           <a:latin typeface="Times New Roman"/>
                         </a:rPr>
-                        <a:t>196.64 Cr</a:t>
+                        <a:t>25.81 Cr</a:t>
                       </a:r>
                     </a:p>
                   </a:txBody>
@@ -14601,7 +14601,7 @@
                           </a:solidFill>
                           <a:latin typeface="Times New Roman"/>
                         </a:rPr>
-                        <a:t>1151191</a:t>
+                        <a:t>115</a:t>
                       </a:r>
                     </a:p>
                   </a:txBody>
@@ -14644,7 +14644,7 @@
                           </a:solidFill>
                           <a:latin typeface="Times New Roman"/>
                         </a:rPr>
-                        <a:t>-1,966,208</a:t>
+                        <a:t>2,133,835</a:t>
                       </a:r>
                       <a:br/>
                       <a:r>
@@ -14654,7 +14654,7 @@
                           </a:solidFill>
                           <a:latin typeface="Times New Roman"/>
                         </a:rPr>
-                        <a:t>-196.62 Cr</a:t>
+                        <a:t>213.38 Cr</a:t>
                       </a:r>
                     </a:p>
                   </a:txBody>
@@ -14697,33 +14697,33 @@
                           </a:solidFill>
                           <a:latin typeface="Times New Roman"/>
                         </a:rPr>
-                        <a:t>479663</a:t>
-                      </a:r>
-                    </a:p>
-                  </a:txBody>
-                  <a:tcPr marL="12000" marR="12000" marT="8000" marB="8000">
-                    <a:lnL w="12700">
-                      <a:solidFill>
-                        <a:srgbClr val="000000"/>
-                      </a:solidFill>
-                    </a:lnL>
-                    <a:lnR w="12700">
-                      <a:solidFill>
-                        <a:srgbClr val="000000"/>
-                      </a:solidFill>
-                    </a:lnR>
-                    <a:lnT w="12700">
-                      <a:solidFill>
-                        <a:srgbClr val="000000"/>
-                      </a:solidFill>
-                    </a:lnT>
-                    <a:lnB w="12700">
-                      <a:solidFill>
-                        <a:srgbClr val="000000"/>
-                      </a:solidFill>
-                    </a:lnB>
-                    <a:solidFill>
-                      <a:srgbClr val="FCE4E4"/>
+                        <a:t>48</a:t>
+                      </a:r>
+                    </a:p>
+                  </a:txBody>
+                  <a:tcPr marL="12000" marR="12000" marT="8000" marB="8000">
+                    <a:lnL w="12700">
+                      <a:solidFill>
+                        <a:srgbClr val="000000"/>
+                      </a:solidFill>
+                    </a:lnL>
+                    <a:lnR w="12700">
+                      <a:solidFill>
+                        <a:srgbClr val="000000"/>
+                      </a:solidFill>
+                    </a:lnR>
+                    <a:lnT w="12700">
+                      <a:solidFill>
+                        <a:srgbClr val="000000"/>
+                      </a:solidFill>
+                    </a:lnT>
+                    <a:lnB w="12700">
+                      <a:solidFill>
+                        <a:srgbClr val="000000"/>
+                      </a:solidFill>
+                    </a:lnB>
+                    <a:solidFill>
+                      <a:srgbClr val="DFF3E7"/>
                     </a:solidFill>
                   </a:tcPr>
                 </a:tc>
@@ -14838,7 +14838,7 @@
                           </a:solidFill>
                           <a:latin typeface="Times New Roman"/>
                         </a:rPr>
-                        <a:t>29</a:t>
+                        <a:t>285,089</a:t>
                       </a:r>
                       <a:br/>
                       <a:r>
@@ -14848,7 +14848,7 @@
                           </a:solidFill>
                           <a:latin typeface="Times New Roman"/>
                         </a:rPr>
-                        <a:t>0.00 Cr</a:t>
+                        <a:t>28.51 Cr</a:t>
                       </a:r>
                     </a:p>
                   </a:txBody>
@@ -14891,7 +14891,7 @@
                           </a:solidFill>
                           <a:latin typeface="Times New Roman"/>
                         </a:rPr>
-                        <a:t>12</a:t>
+                        <a:t>118,787</a:t>
                       </a:r>
                       <a:br/>
                       <a:r>
@@ -14901,7 +14901,7 @@
                           </a:solidFill>
                           <a:latin typeface="Times New Roman"/>
                         </a:rPr>
-                        <a:t>0.00 Cr</a:t>
+                        <a:t>11.88 Cr</a:t>
                       </a:r>
                     </a:p>
                   </a:txBody>
@@ -14997,7 +14997,7 @@
                           </a:solidFill>
                           <a:latin typeface="Times New Roman"/>
                         </a:rPr>
-                        <a:t>60</a:t>
+                        <a:t>-118,715</a:t>
                       </a:r>
                       <a:br/>
                       <a:r>
@@ -15007,7 +15007,7 @@
                           </a:solidFill>
                           <a:latin typeface="Times New Roman"/>
                         </a:rPr>
-                        <a:t>0.01 Cr</a:t>
+                        <a:t>-11.87 Cr</a:t>
                       </a:r>
                     </a:p>
                   </a:txBody>
@@ -15050,33 +15050,33 @@
                           </a:solidFill>
                           <a:latin typeface="Times New Roman"/>
                         </a:rPr>
-                        <a:t>596</a:t>
-                      </a:r>
-                    </a:p>
-                  </a:txBody>
-                  <a:tcPr marL="12000" marR="12000" marT="8000" marB="8000">
-                    <a:lnL w="12700">
-                      <a:solidFill>
-                        <a:srgbClr val="000000"/>
-                      </a:solidFill>
-                    </a:lnL>
-                    <a:lnR w="12700">
-                      <a:solidFill>
-                        <a:srgbClr val="000000"/>
-                      </a:solidFill>
-                    </a:lnR>
-                    <a:lnT w="12700">
-                      <a:solidFill>
-                        <a:srgbClr val="000000"/>
-                      </a:solidFill>
-                    </a:lnT>
-                    <a:lnB w="12700">
-                      <a:solidFill>
-                        <a:srgbClr val="000000"/>
-                      </a:solidFill>
-                    </a:lnB>
-                    <a:solidFill>
-                      <a:srgbClr val="FCE4E4"/>
+                        <a:t>0</a:t>
+                      </a:r>
+                    </a:p>
+                  </a:txBody>
+                  <a:tcPr marL="12000" marR="12000" marT="8000" marB="8000">
+                    <a:lnL w="12700">
+                      <a:solidFill>
+                        <a:srgbClr val="000000"/>
+                      </a:solidFill>
+                    </a:lnL>
+                    <a:lnR w="12700">
+                      <a:solidFill>
+                        <a:srgbClr val="000000"/>
+                      </a:solidFill>
+                    </a:lnR>
+                    <a:lnT w="12700">
+                      <a:solidFill>
+                        <a:srgbClr val="000000"/>
+                      </a:solidFill>
+                    </a:lnT>
+                    <a:lnB w="12700">
+                      <a:solidFill>
+                        <a:srgbClr val="000000"/>
+                      </a:solidFill>
+                    </a:lnB>
+                    <a:solidFill>
+                      <a:srgbClr val="DFF3E7"/>
                     </a:solidFill>
                   </a:tcPr>
                 </a:tc>
@@ -15093,7 +15093,7 @@
                           </a:solidFill>
                           <a:latin typeface="Times New Roman"/>
                         </a:rPr>
-                        <a:t>-43</a:t>
+                        <a:t>285,017</a:t>
                       </a:r>
                       <a:br/>
                       <a:r>
@@ -15103,7 +15103,7 @@
                           </a:solidFill>
                           <a:latin typeface="Times New Roman"/>
                         </a:rPr>
-                        <a:t>-0.00 Cr</a:t>
+                        <a:t>28.50 Cr</a:t>
                       </a:r>
                     </a:p>
                   </a:txBody>
@@ -15146,33 +15146,33 @@
                           </a:solidFill>
                           <a:latin typeface="Times New Roman"/>
                         </a:rPr>
-                        <a:t>248</a:t>
-                      </a:r>
-                    </a:p>
-                  </a:txBody>
-                  <a:tcPr marL="12000" marR="12000" marT="8000" marB="8000">
-                    <a:lnL w="12700">
-                      <a:solidFill>
-                        <a:srgbClr val="000000"/>
-                      </a:solidFill>
-                    </a:lnL>
-                    <a:lnR w="12700">
-                      <a:solidFill>
-                        <a:srgbClr val="000000"/>
-                      </a:solidFill>
-                    </a:lnR>
-                    <a:lnT w="12700">
-                      <a:solidFill>
-                        <a:srgbClr val="000000"/>
-                      </a:solidFill>
-                    </a:lnT>
-                    <a:lnB w="12700">
-                      <a:solidFill>
-                        <a:srgbClr val="000000"/>
-                      </a:solidFill>
-                    </a:lnB>
-                    <a:solidFill>
-                      <a:srgbClr val="FCE4E4"/>
+                        <a:t>0</a:t>
+                      </a:r>
+                    </a:p>
+                  </a:txBody>
+                  <a:tcPr marL="12000" marR="12000" marT="8000" marB="8000">
+                    <a:lnL w="12700">
+                      <a:solidFill>
+                        <a:srgbClr val="000000"/>
+                      </a:solidFill>
+                    </a:lnL>
+                    <a:lnR w="12700">
+                      <a:solidFill>
+                        <a:srgbClr val="000000"/>
+                      </a:solidFill>
+                    </a:lnR>
+                    <a:lnT w="12700">
+                      <a:solidFill>
+                        <a:srgbClr val="000000"/>
+                      </a:solidFill>
+                    </a:lnT>
+                    <a:lnB w="12700">
+                      <a:solidFill>
+                        <a:srgbClr val="000000"/>
+                      </a:solidFill>
+                    </a:lnB>
+                    <a:solidFill>
+                      <a:srgbClr val="DFF3E7"/>
                     </a:solidFill>
                   </a:tcPr>
                 </a:tc>
@@ -15287,7 +15287,7 @@
                           </a:solidFill>
                           <a:latin typeface="Times New Roman"/>
                         </a:rPr>
-                        <a:t>78</a:t>
+                        <a:t>776,198</a:t>
                       </a:r>
                       <a:br/>
                       <a:r>
@@ -15297,7 +15297,7 @@
                           </a:solidFill>
                           <a:latin typeface="Times New Roman"/>
                         </a:rPr>
-                        <a:t>0.01 Cr</a:t>
+                        <a:t>77.62 Cr</a:t>
                       </a:r>
                     </a:p>
                   </a:txBody>
@@ -15340,7 +15340,7 @@
                           </a:solidFill>
                           <a:latin typeface="Times New Roman"/>
                         </a:rPr>
-                        <a:t>32</a:t>
+                        <a:t>323,416</a:t>
                       </a:r>
                       <a:br/>
                       <a:r>
@@ -15350,7 +15350,7 @@
                           </a:solidFill>
                           <a:latin typeface="Times New Roman"/>
                         </a:rPr>
-                        <a:t>0.00 Cr</a:t>
+                        <a:t>32.34 Cr</a:t>
                       </a:r>
                     </a:p>
                   </a:txBody>
@@ -15446,7 +15446,7 @@
                           </a:solidFill>
                           <a:latin typeface="Times New Roman"/>
                         </a:rPr>
-                        <a:t>337,330</a:t>
+                        <a:t>13,946</a:t>
                       </a:r>
                       <a:br/>
                       <a:r>
@@ -15456,7 +15456,7 @@
                           </a:solidFill>
                           <a:latin typeface="Times New Roman"/>
                         </a:rPr>
-                        <a:t>33.73 Cr</a:t>
+                        <a:t>1.39 Cr</a:t>
                       </a:r>
                     </a:p>
                   </a:txBody>
@@ -15499,7 +15499,7 @@
                           </a:solidFill>
                           <a:latin typeface="Times New Roman"/>
                         </a:rPr>
-                        <a:t>1038037</a:t>
+                        <a:t>104</a:t>
                       </a:r>
                     </a:p>
                   </a:txBody>
@@ -15542,7 +15542,7 @@
                           </a:solidFill>
                           <a:latin typeface="Times New Roman"/>
                         </a:rPr>
-                        <a:t>-337,284</a:t>
+                        <a:t>438,836</a:t>
                       </a:r>
                       <a:br/>
                       <a:r>
@@ -15552,7 +15552,7 @@
                           </a:solidFill>
                           <a:latin typeface="Times New Roman"/>
                         </a:rPr>
-                        <a:t>-33.73 Cr</a:t>
+                        <a:t>43.88 Cr</a:t>
                       </a:r>
                     </a:p>
                   </a:txBody>
@@ -15595,33 +15595,33 @@
                           </a:solidFill>
                           <a:latin typeface="Times New Roman"/>
                         </a:rPr>
-                        <a:t>432515</a:t>
-                      </a:r>
-                    </a:p>
-                  </a:txBody>
-                  <a:tcPr marL="12000" marR="12000" marT="8000" marB="8000">
-                    <a:lnL w="12700">
-                      <a:solidFill>
-                        <a:srgbClr val="000000"/>
-                      </a:solidFill>
-                    </a:lnL>
-                    <a:lnR w="12700">
-                      <a:solidFill>
-                        <a:srgbClr val="000000"/>
-                      </a:solidFill>
-                    </a:lnR>
-                    <a:lnT w="12700">
-                      <a:solidFill>
-                        <a:srgbClr val="000000"/>
-                      </a:solidFill>
-                    </a:lnT>
-                    <a:lnB w="12700">
-                      <a:solidFill>
-                        <a:srgbClr val="000000"/>
-                      </a:solidFill>
-                    </a:lnB>
-                    <a:solidFill>
-                      <a:srgbClr val="FCE4E4"/>
+                        <a:t>43</a:t>
+                      </a:r>
+                    </a:p>
+                  </a:txBody>
+                  <a:tcPr marL="12000" marR="12000" marT="8000" marB="8000">
+                    <a:lnL w="12700">
+                      <a:solidFill>
+                        <a:srgbClr val="000000"/>
+                      </a:solidFill>
+                    </a:lnL>
+                    <a:lnR w="12700">
+                      <a:solidFill>
+                        <a:srgbClr val="000000"/>
+                      </a:solidFill>
+                    </a:lnR>
+                    <a:lnT w="12700">
+                      <a:solidFill>
+                        <a:srgbClr val="000000"/>
+                      </a:solidFill>
+                    </a:lnT>
+                    <a:lnB w="12700">
+                      <a:solidFill>
+                        <a:srgbClr val="000000"/>
+                      </a:solidFill>
+                    </a:lnB>
+                    <a:solidFill>
+                      <a:srgbClr val="DFF3E7"/>
                     </a:solidFill>
                   </a:tcPr>
                 </a:tc>
@@ -15736,7 +15736,7 @@
                           </a:solidFill>
                           <a:latin typeface="Times New Roman"/>
                         </a:rPr>
-                        <a:t>50</a:t>
+                        <a:t>496,609</a:t>
                       </a:r>
                       <a:br/>
                       <a:r>
@@ -15746,7 +15746,7 @@
                           </a:solidFill>
                           <a:latin typeface="Times New Roman"/>
                         </a:rPr>
-                        <a:t>0.01 Cr</a:t>
+                        <a:t>49.66 Cr</a:t>
                       </a:r>
                     </a:p>
                   </a:txBody>
@@ -15789,7 +15789,7 @@
                           </a:solidFill>
                           <a:latin typeface="Times New Roman"/>
                         </a:rPr>
-                        <a:t>21</a:t>
+                        <a:t>206,920</a:t>
                       </a:r>
                       <a:br/>
                       <a:r>
@@ -15799,7 +15799,7 @@
                           </a:solidFill>
                           <a:latin typeface="Times New Roman"/>
                         </a:rPr>
-                        <a:t>0.00 Cr</a:t>
+                        <a:t>20.69 Cr</a:t>
                       </a:r>
                     </a:p>
                   </a:txBody>
@@ -15895,7 +15895,7 @@
                           </a:solidFill>
                           <a:latin typeface="Times New Roman"/>
                         </a:rPr>
-                        <a:t>216,376</a:t>
+                        <a:t>9,477</a:t>
                       </a:r>
                       <a:br/>
                       <a:r>
@@ -15905,7 +15905,7 @@
                           </a:solidFill>
                           <a:latin typeface="Times New Roman"/>
                         </a:rPr>
-                        <a:t>21.64 Cr</a:t>
+                        <a:t>0.95 Cr</a:t>
                       </a:r>
                     </a:p>
                   </a:txBody>
@@ -15948,7 +15948,7 @@
                           </a:solidFill>
                           <a:latin typeface="Times New Roman"/>
                         </a:rPr>
-                        <a:t>1038706</a:t>
+                        <a:t>105</a:t>
                       </a:r>
                     </a:p>
                   </a:txBody>
@@ -15991,7 +15991,7 @@
                           </a:solidFill>
                           <a:latin typeface="Times New Roman"/>
                         </a:rPr>
-                        <a:t>-216,347</a:t>
+                        <a:t>280,212</a:t>
                       </a:r>
                       <a:br/>
                       <a:r>
@@ -16001,7 +16001,7 @@
                           </a:solidFill>
                           <a:latin typeface="Times New Roman"/>
                         </a:rPr>
-                        <a:t>-21.63 Cr</a:t>
+                        <a:t>28.02 Cr</a:t>
                       </a:r>
                     </a:p>
                   </a:txBody>
@@ -16044,33 +16044,33 @@
                           </a:solidFill>
                           <a:latin typeface="Times New Roman"/>
                         </a:rPr>
-                        <a:t>432794</a:t>
-                      </a:r>
-                    </a:p>
-                  </a:txBody>
-                  <a:tcPr marL="12000" marR="12000" marT="8000" marB="8000">
-                    <a:lnL w="12700">
-                      <a:solidFill>
-                        <a:srgbClr val="000000"/>
-                      </a:solidFill>
-                    </a:lnL>
-                    <a:lnR w="12700">
-                      <a:solidFill>
-                        <a:srgbClr val="000000"/>
-                      </a:solidFill>
-                    </a:lnR>
-                    <a:lnT w="12700">
-                      <a:solidFill>
-                        <a:srgbClr val="000000"/>
-                      </a:solidFill>
-                    </a:lnT>
-                    <a:lnB w="12700">
-                      <a:solidFill>
-                        <a:srgbClr val="000000"/>
-                      </a:solidFill>
-                    </a:lnB>
-                    <a:solidFill>
-                      <a:srgbClr val="FCE4E4"/>
+                        <a:t>44</a:t>
+                      </a:r>
+                    </a:p>
+                  </a:txBody>
+                  <a:tcPr marL="12000" marR="12000" marT="8000" marB="8000">
+                    <a:lnL w="12700">
+                      <a:solidFill>
+                        <a:srgbClr val="000000"/>
+                      </a:solidFill>
+                    </a:lnL>
+                    <a:lnR w="12700">
+                      <a:solidFill>
+                        <a:srgbClr val="000000"/>
+                      </a:solidFill>
+                    </a:lnR>
+                    <a:lnT w="12700">
+                      <a:solidFill>
+                        <a:srgbClr val="000000"/>
+                      </a:solidFill>
+                    </a:lnT>
+                    <a:lnB w="12700">
+                      <a:solidFill>
+                        <a:srgbClr val="000000"/>
+                      </a:solidFill>
+                    </a:lnB>
+                    <a:solidFill>
+                      <a:srgbClr val="DFF3E7"/>
                     </a:solidFill>
                   </a:tcPr>
                 </a:tc>
@@ -16185,7 +16185,7 @@
                           </a:solidFill>
                           <a:latin typeface="Times New Roman"/>
                         </a:rPr>
-                        <a:t>68</a:t>
+                        <a:t>680,197</a:t>
                       </a:r>
                       <a:br/>
                       <a:r>
@@ -16195,7 +16195,7 @@
                           </a:solidFill>
                           <a:latin typeface="Times New Roman"/>
                         </a:rPr>
-                        <a:t>0.01 Cr</a:t>
+                        <a:t>68.02 Cr</a:t>
                       </a:r>
                     </a:p>
                   </a:txBody>
@@ -16238,7 +16238,7 @@
                           </a:solidFill>
                           <a:latin typeface="Times New Roman"/>
                         </a:rPr>
-                        <a:t>28</a:t>
+                        <a:t>283,415</a:t>
                       </a:r>
                       <a:br/>
                       <a:r>
@@ -16248,7 +16248,7 @@
                           </a:solidFill>
                           <a:latin typeface="Times New Roman"/>
                         </a:rPr>
-                        <a:t>0.00 Cr</a:t>
+                        <a:t>28.34 Cr</a:t>
                       </a:r>
                     </a:p>
                   </a:txBody>
@@ -16344,7 +16344,7 @@
                           </a:solidFill>
                           <a:latin typeface="Times New Roman"/>
                         </a:rPr>
-                        <a:t>364,625</a:t>
+                        <a:t>81,238</a:t>
                       </a:r>
                       <a:br/>
                       <a:r>
@@ -16354,7 +16354,7 @@
                           </a:solidFill>
                           <a:latin typeface="Times New Roman"/>
                         </a:rPr>
-                        <a:t>36.46 Cr</a:t>
+                        <a:t>8.12 Cr</a:t>
                       </a:r>
                     </a:p>
                   </a:txBody>
@@ -16397,7 +16397,7 @@
                           </a:solidFill>
                           <a:latin typeface="Times New Roman"/>
                         </a:rPr>
-                        <a:t>1287011</a:t>
+                        <a:t>129</a:t>
                       </a:r>
                     </a:p>
                   </a:txBody>
@@ -16440,7 +16440,7 @@
                           </a:solidFill>
                           <a:latin typeface="Times New Roman"/>
                         </a:rPr>
-                        <a:t>-364,585</a:t>
+                        <a:t>315,544</a:t>
                       </a:r>
                       <a:br/>
                       <a:r>
@@ -16450,7 +16450,7 @@
                           </a:solidFill>
                           <a:latin typeface="Times New Roman"/>
                         </a:rPr>
-                        <a:t>-36.46 Cr</a:t>
+                        <a:t>31.55 Cr</a:t>
                       </a:r>
                     </a:p>
                   </a:txBody>
@@ -16493,33 +16493,33 @@
                           </a:solidFill>
                           <a:latin typeface="Times New Roman"/>
                         </a:rPr>
-                        <a:t>536254</a:t>
-                      </a:r>
-                    </a:p>
-                  </a:txBody>
-                  <a:tcPr marL="12000" marR="12000" marT="8000" marB="8000">
-                    <a:lnL w="12700">
-                      <a:solidFill>
-                        <a:srgbClr val="000000"/>
-                      </a:solidFill>
-                    </a:lnL>
-                    <a:lnR w="12700">
-                      <a:solidFill>
-                        <a:srgbClr val="000000"/>
-                      </a:solidFill>
-                    </a:lnR>
-                    <a:lnT w="12700">
-                      <a:solidFill>
-                        <a:srgbClr val="000000"/>
-                      </a:solidFill>
-                    </a:lnT>
-                    <a:lnB w="12700">
-                      <a:solidFill>
-                        <a:srgbClr val="000000"/>
-                      </a:solidFill>
-                    </a:lnB>
-                    <a:solidFill>
-                      <a:srgbClr val="FCE4E4"/>
+                        <a:t>54</a:t>
+                      </a:r>
+                    </a:p>
+                  </a:txBody>
+                  <a:tcPr marL="12000" marR="12000" marT="8000" marB="8000">
+                    <a:lnL w="12700">
+                      <a:solidFill>
+                        <a:srgbClr val="000000"/>
+                      </a:solidFill>
+                    </a:lnL>
+                    <a:lnR w="12700">
+                      <a:solidFill>
+                        <a:srgbClr val="000000"/>
+                      </a:solidFill>
+                    </a:lnR>
+                    <a:lnT w="12700">
+                      <a:solidFill>
+                        <a:srgbClr val="000000"/>
+                      </a:solidFill>
+                    </a:lnT>
+                    <a:lnB w="12700">
+                      <a:solidFill>
+                        <a:srgbClr val="000000"/>
+                      </a:solidFill>
+                    </a:lnB>
+                    <a:solidFill>
+                      <a:srgbClr val="DFF3E7"/>
                     </a:solidFill>
                   </a:tcPr>
                 </a:tc>
@@ -16634,7 +16634,7 @@
                           </a:solidFill>
                           <a:latin typeface="Times New Roman"/>
                         </a:rPr>
-                        <a:t>8</a:t>
+                        <a:t>77,300</a:t>
                       </a:r>
                       <a:br/>
                       <a:r>
@@ -16644,7 +16644,7 @@
                           </a:solidFill>
                           <a:latin typeface="Times New Roman"/>
                         </a:rPr>
-                        <a:t>0.00 Cr</a:t>
+                        <a:t>7.73 Cr</a:t>
                       </a:r>
                     </a:p>
                   </a:txBody>
@@ -16687,7 +16687,7 @@
                           </a:solidFill>
                           <a:latin typeface="Times New Roman"/>
                         </a:rPr>
-                        <a:t>3</a:t>
+                        <a:t>32,208</a:t>
                       </a:r>
                       <a:br/>
                       <a:r>
@@ -16697,7 +16697,7 @@
                           </a:solidFill>
                           <a:latin typeface="Times New Roman"/>
                         </a:rPr>
-                        <a:t>0.00 Cr</a:t>
+                        <a:t>3.22 Cr</a:t>
                       </a:r>
                     </a:p>
                   </a:txBody>
@@ -16793,7 +16793,7 @@
                           </a:solidFill>
                           <a:latin typeface="Times New Roman"/>
                         </a:rPr>
-                        <a:t>59,579</a:t>
+                        <a:t>27,374</a:t>
                       </a:r>
                       <a:br/>
                       <a:r>
@@ -16803,7 +16803,7 @@
                           </a:solidFill>
                           <a:latin typeface="Times New Roman"/>
                         </a:rPr>
-                        <a:t>5.96 Cr</a:t>
+                        <a:t>2.74 Cr</a:t>
                       </a:r>
                     </a:p>
                   </a:txBody>
@@ -16846,7 +16846,7 @@
                           </a:solidFill>
                           <a:latin typeface="Times New Roman"/>
                         </a:rPr>
-                        <a:t>1787460</a:t>
+                        <a:t>185</a:t>
                       </a:r>
                     </a:p>
                   </a:txBody>
@@ -16889,7 +16889,7 @@
                           </a:solidFill>
                           <a:latin typeface="Times New Roman"/>
                         </a:rPr>
-                        <a:t>-59,574</a:t>
+                        <a:t>17,718</a:t>
                       </a:r>
                       <a:br/>
                       <a:r>
@@ -16899,7 +16899,7 @@
                           </a:solidFill>
                           <a:latin typeface="Times New Roman"/>
                         </a:rPr>
-                        <a:t>-5.96 Cr</a:t>
+                        <a:t>1.77 Cr</a:t>
                       </a:r>
                     </a:p>
                   </a:txBody>
@@ -16942,33 +16942,33 @@
                           </a:solidFill>
                           <a:latin typeface="Times New Roman"/>
                         </a:rPr>
-                        <a:t>744775</a:t>
-                      </a:r>
-                    </a:p>
-                  </a:txBody>
-                  <a:tcPr marL="12000" marR="12000" marT="8000" marB="8000">
-                    <a:lnL w="12700">
-                      <a:solidFill>
-                        <a:srgbClr val="000000"/>
-                      </a:solidFill>
-                    </a:lnL>
-                    <a:lnR w="12700">
-                      <a:solidFill>
-                        <a:srgbClr val="000000"/>
-                      </a:solidFill>
-                    </a:lnR>
-                    <a:lnT w="12700">
-                      <a:solidFill>
-                        <a:srgbClr val="000000"/>
-                      </a:solidFill>
-                    </a:lnT>
-                    <a:lnB w="12700">
-                      <a:solidFill>
-                        <a:srgbClr val="000000"/>
-                      </a:solidFill>
-                    </a:lnB>
-                    <a:solidFill>
-                      <a:srgbClr val="FCE4E4"/>
+                        <a:t>77</a:t>
+                      </a:r>
+                    </a:p>
+                  </a:txBody>
+                  <a:tcPr marL="12000" marR="12000" marT="8000" marB="8000">
+                    <a:lnL w="12700">
+                      <a:solidFill>
+                        <a:srgbClr val="000000"/>
+                      </a:solidFill>
+                    </a:lnL>
+                    <a:lnR w="12700">
+                      <a:solidFill>
+                        <a:srgbClr val="000000"/>
+                      </a:solidFill>
+                    </a:lnR>
+                    <a:lnT w="12700">
+                      <a:solidFill>
+                        <a:srgbClr val="000000"/>
+                      </a:solidFill>
+                    </a:lnT>
+                    <a:lnB w="12700">
+                      <a:solidFill>
+                        <a:srgbClr val="000000"/>
+                      </a:solidFill>
+                    </a:lnB>
+                    <a:solidFill>
+                      <a:srgbClr val="FFF2CC"/>
                     </a:solidFill>
                   </a:tcPr>
                 </a:tc>
@@ -17083,7 +17083,7 @@
                           </a:solidFill>
                           <a:latin typeface="Times New Roman"/>
                         </a:rPr>
-                        <a:t>21</a:t>
+                        <a:t>209,913</a:t>
                       </a:r>
                       <a:br/>
                       <a:r>
@@ -17093,7 +17093,7 @@
                           </a:solidFill>
                           <a:latin typeface="Times New Roman"/>
                         </a:rPr>
-                        <a:t>0.00 Cr</a:t>
+                        <a:t>20.99 Cr</a:t>
                       </a:r>
                     </a:p>
                   </a:txBody>
@@ -17136,7 +17136,7 @@
                           </a:solidFill>
                           <a:latin typeface="Times New Roman"/>
                         </a:rPr>
-                        <a:t>9</a:t>
+                        <a:t>87,464</a:t>
                       </a:r>
                       <a:br/>
                       <a:r>
@@ -17146,7 +17146,7 @@
                           </a:solidFill>
                           <a:latin typeface="Times New Roman"/>
                         </a:rPr>
-                        <a:t>0.00 Cr</a:t>
+                        <a:t>8.75 Cr</a:t>
                       </a:r>
                     </a:p>
                   </a:txBody>
@@ -17242,7 +17242,7 @@
                           </a:solidFill>
                           <a:latin typeface="Times New Roman"/>
                         </a:rPr>
-                        <a:t>122,483</a:t>
+                        <a:t>35,028</a:t>
                       </a:r>
                       <a:br/>
                       <a:r>
@@ -17252,7 +17252,7 @@
                           </a:solidFill>
                           <a:latin typeface="Times New Roman"/>
                         </a:rPr>
-                        <a:t>12.25 Cr</a:t>
+                        <a:t>3.50 Cr</a:t>
                       </a:r>
                     </a:p>
                   </a:txBody>
@@ -17295,7 +17295,7 @@
                           </a:solidFill>
                           <a:latin typeface="Times New Roman"/>
                         </a:rPr>
-                        <a:t>1399909</a:t>
+                        <a:t>140</a:t>
                       </a:r>
                     </a:p>
                   </a:txBody>
@@ -17338,7 +17338,7 @@
                           </a:solidFill>
                           <a:latin typeface="Times New Roman"/>
                         </a:rPr>
-                        <a:t>-122,471</a:t>
+                        <a:t>87,421</a:t>
                       </a:r>
                       <a:br/>
                       <a:r>
@@ -17348,7 +17348,7 @@
                           </a:solidFill>
                           <a:latin typeface="Times New Roman"/>
                         </a:rPr>
-                        <a:t>-12.25 Cr</a:t>
+                        <a:t>8.74 Cr</a:t>
                       </a:r>
                     </a:p>
                   </a:txBody>
@@ -17391,33 +17391,33 @@
                           </a:solidFill>
                           <a:latin typeface="Times New Roman"/>
                         </a:rPr>
-                        <a:t>583295</a:t>
-                      </a:r>
-                    </a:p>
-                  </a:txBody>
-                  <a:tcPr marL="12000" marR="12000" marT="8000" marB="8000">
-                    <a:lnL w="12700">
-                      <a:solidFill>
-                        <a:srgbClr val="000000"/>
-                      </a:solidFill>
-                    </a:lnL>
-                    <a:lnR w="12700">
-                      <a:solidFill>
-                        <a:srgbClr val="000000"/>
-                      </a:solidFill>
-                    </a:lnR>
-                    <a:lnT w="12700">
-                      <a:solidFill>
-                        <a:srgbClr val="000000"/>
-                      </a:solidFill>
-                    </a:lnT>
-                    <a:lnB w="12700">
-                      <a:solidFill>
-                        <a:srgbClr val="000000"/>
-                      </a:solidFill>
-                    </a:lnB>
-                    <a:solidFill>
-                      <a:srgbClr val="FCE4E4"/>
+                        <a:t>58</a:t>
+                      </a:r>
+                    </a:p>
+                  </a:txBody>
+                  <a:tcPr marL="12000" marR="12000" marT="8000" marB="8000">
+                    <a:lnL w="12700">
+                      <a:solidFill>
+                        <a:srgbClr val="000000"/>
+                      </a:solidFill>
+                    </a:lnL>
+                    <a:lnR w="12700">
+                      <a:solidFill>
+                        <a:srgbClr val="000000"/>
+                      </a:solidFill>
+                    </a:lnR>
+                    <a:lnT w="12700">
+                      <a:solidFill>
+                        <a:srgbClr val="000000"/>
+                      </a:solidFill>
+                    </a:lnT>
+                    <a:lnB w="12700">
+                      <a:solidFill>
+                        <a:srgbClr val="000000"/>
+                      </a:solidFill>
+                    </a:lnB>
+                    <a:solidFill>
+                      <a:srgbClr val="DFF3E7"/>
                     </a:solidFill>
                   </a:tcPr>
                 </a:tc>
@@ -17532,341 +17532,341 @@
                           </a:solidFill>
                           <a:latin typeface="Times New Roman"/>
                         </a:rPr>
+                        <a:t>527,832</a:t>
+                      </a:r>
+                      <a:br/>
+                      <a:r>
+                        <a:rPr lang="en-US" sz="820">
+                          <a:solidFill>
+                            <a:srgbClr val="006F78"/>
+                          </a:solidFill>
+                          <a:latin typeface="Times New Roman"/>
+                        </a:rPr>
+                        <a:t>52.78 Cr</a:t>
+                      </a:r>
+                    </a:p>
+                  </a:txBody>
+                  <a:tcPr marL="12000" marR="12000" marT="8000" marB="8000">
+                    <a:lnL w="12700">
+                      <a:solidFill>
+                        <a:srgbClr val="000000"/>
+                      </a:solidFill>
+                    </a:lnL>
+                    <a:lnR w="12700">
+                      <a:solidFill>
+                        <a:srgbClr val="000000"/>
+                      </a:solidFill>
+                    </a:lnR>
+                    <a:lnT w="12700">
+                      <a:solidFill>
+                        <a:srgbClr val="000000"/>
+                      </a:solidFill>
+                    </a:lnT>
+                    <a:lnB w="12700">
+                      <a:solidFill>
+                        <a:srgbClr val="000000"/>
+                      </a:solidFill>
+                    </a:lnB>
+                    <a:solidFill>
+                      <a:srgbClr val="FFFFFF"/>
+                    </a:solidFill>
+                  </a:tcPr>
+                </a:tc>
+                <a:tc>
+                  <a:txBody>
+                    <a:bodyPr wrap="square" anchor="ctr" lIns="18000" rIns="18000" tIns="10000" bIns="10000"/>
+                    <a:lstStyle/>
+                    <a:p>
+                      <a:pPr algn="ctr"/>
+                      <a:r>
+                        <a:rPr lang="en-US" sz="1000">
+                          <a:solidFill>
+                            <a:srgbClr val="000000"/>
+                          </a:solidFill>
+                          <a:latin typeface="Times New Roman"/>
+                        </a:rPr>
+                        <a:t>219,930</a:t>
+                      </a:r>
+                      <a:br/>
+                      <a:r>
+                        <a:rPr lang="en-US" sz="820">
+                          <a:solidFill>
+                            <a:srgbClr val="006F78"/>
+                          </a:solidFill>
+                          <a:latin typeface="Times New Roman"/>
+                        </a:rPr>
+                        <a:t>21.99 Cr</a:t>
+                      </a:r>
+                    </a:p>
+                  </a:txBody>
+                  <a:tcPr marL="12000" marR="12000" marT="8000" marB="8000">
+                    <a:lnL w="12700">
+                      <a:solidFill>
+                        <a:srgbClr val="000000"/>
+                      </a:solidFill>
+                    </a:lnL>
+                    <a:lnR w="12700">
+                      <a:solidFill>
+                        <a:srgbClr val="000000"/>
+                      </a:solidFill>
+                    </a:lnR>
+                    <a:lnT w="12700">
+                      <a:solidFill>
+                        <a:srgbClr val="000000"/>
+                      </a:solidFill>
+                    </a:lnT>
+                    <a:lnB w="12700">
+                      <a:solidFill>
+                        <a:srgbClr val="000000"/>
+                      </a:solidFill>
+                    </a:lnB>
+                    <a:solidFill>
+                      <a:srgbClr val="FFFFFF"/>
+                    </a:solidFill>
+                  </a:tcPr>
+                </a:tc>
+                <a:tc>
+                  <a:txBody>
+                    <a:bodyPr wrap="square" anchor="ctr" lIns="18000" rIns="18000" tIns="10000" bIns="10000"/>
+                    <a:lstStyle/>
+                    <a:p>
+                      <a:pPr algn="ctr"/>
+                      <a:r>
+                        <a:rPr lang="en-US" sz="1000">
+                          <a:solidFill>
+                            <a:srgbClr val="000000"/>
+                          </a:solidFill>
+                          <a:latin typeface="Times New Roman"/>
+                        </a:rPr>
+                        <a:t>278,899</a:t>
+                      </a:r>
+                      <a:br/>
+                      <a:r>
+                        <a:rPr lang="en-US" sz="820">
+                          <a:solidFill>
+                            <a:srgbClr val="006F78"/>
+                          </a:solidFill>
+                          <a:latin typeface="Times New Roman"/>
+                        </a:rPr>
+                        <a:t>27.89 Cr</a:t>
+                      </a:r>
+                    </a:p>
+                  </a:txBody>
+                  <a:tcPr marL="12000" marR="12000" marT="8000" marB="8000">
+                    <a:lnL w="12700">
+                      <a:solidFill>
+                        <a:srgbClr val="000000"/>
+                      </a:solidFill>
+                    </a:lnL>
+                    <a:lnR w="12700">
+                      <a:solidFill>
+                        <a:srgbClr val="000000"/>
+                      </a:solidFill>
+                    </a:lnR>
+                    <a:lnT w="12700">
+                      <a:solidFill>
+                        <a:srgbClr val="000000"/>
+                      </a:solidFill>
+                    </a:lnT>
+                    <a:lnB w="12700">
+                      <a:solidFill>
+                        <a:srgbClr val="000000"/>
+                      </a:solidFill>
+                    </a:lnB>
+                    <a:solidFill>
+                      <a:srgbClr val="FFFFFF"/>
+                    </a:solidFill>
+                  </a:tcPr>
+                </a:tc>
+                <a:tc>
+                  <a:txBody>
+                    <a:bodyPr wrap="square" anchor="ctr" lIns="18000" rIns="18000" tIns="10000" bIns="10000"/>
+                    <a:lstStyle/>
+                    <a:p>
+                      <a:pPr algn="ctr"/>
+                      <a:r>
+                        <a:rPr lang="en-US" sz="1000">
+                          <a:solidFill>
+                            <a:srgbClr val="000000"/>
+                          </a:solidFill>
+                          <a:latin typeface="Times New Roman"/>
+                        </a:rPr>
+                        <a:t>58,969</a:t>
+                      </a:r>
+                      <a:br/>
+                      <a:r>
+                        <a:rPr lang="en-US" sz="820">
+                          <a:solidFill>
+                            <a:srgbClr val="006F78"/>
+                          </a:solidFill>
+                          <a:latin typeface="Times New Roman"/>
+                        </a:rPr>
+                        <a:t>5.90 Cr</a:t>
+                      </a:r>
+                    </a:p>
+                  </a:txBody>
+                  <a:tcPr marL="12000" marR="12000" marT="8000" marB="8000">
+                    <a:lnL w="12700">
+                      <a:solidFill>
+                        <a:srgbClr val="000000"/>
+                      </a:solidFill>
+                    </a:lnL>
+                    <a:lnR w="12700">
+                      <a:solidFill>
+                        <a:srgbClr val="000000"/>
+                      </a:solidFill>
+                    </a:lnR>
+                    <a:lnT w="12700">
+                      <a:solidFill>
+                        <a:srgbClr val="000000"/>
+                      </a:solidFill>
+                    </a:lnT>
+                    <a:lnB w="12700">
+                      <a:solidFill>
+                        <a:srgbClr val="000000"/>
+                      </a:solidFill>
+                    </a:lnB>
+                    <a:solidFill>
+                      <a:srgbClr val="FFFFFF"/>
+                    </a:solidFill>
+                  </a:tcPr>
+                </a:tc>
+                <a:tc>
+                  <a:txBody>
+                    <a:bodyPr wrap="square" anchor="ctr" lIns="18000" rIns="18000" tIns="10000" bIns="10000"/>
+                    <a:lstStyle/>
+                    <a:p>
+                      <a:pPr algn="ctr"/>
+                      <a:r>
+                        <a:rPr lang="en-US" sz="1000" b="1">
+                          <a:solidFill>
+                            <a:srgbClr val="000000"/>
+                          </a:solidFill>
+                          <a:latin typeface="Times New Roman"/>
+                        </a:rPr>
+                        <a:t>127</a:t>
+                      </a:r>
+                    </a:p>
+                  </a:txBody>
+                  <a:tcPr marL="12000" marR="12000" marT="8000" marB="8000">
+                    <a:lnL w="12700">
+                      <a:solidFill>
+                        <a:srgbClr val="000000"/>
+                      </a:solidFill>
+                    </a:lnL>
+                    <a:lnR w="12700">
+                      <a:solidFill>
+                        <a:srgbClr val="000000"/>
+                      </a:solidFill>
+                    </a:lnR>
+                    <a:lnT w="12700">
+                      <a:solidFill>
+                        <a:srgbClr val="000000"/>
+                      </a:solidFill>
+                    </a:lnT>
+                    <a:lnB w="12700">
+                      <a:solidFill>
+                        <a:srgbClr val="000000"/>
+                      </a:solidFill>
+                    </a:lnB>
+                    <a:solidFill>
+                      <a:srgbClr val="FCE4E4"/>
+                    </a:solidFill>
+                  </a:tcPr>
+                </a:tc>
+                <a:tc>
+                  <a:txBody>
+                    <a:bodyPr wrap="square" anchor="ctr" lIns="18000" rIns="18000" tIns="10000" bIns="10000"/>
+                    <a:lstStyle/>
+                    <a:p>
+                      <a:pPr algn="ctr"/>
+                      <a:r>
+                        <a:rPr lang="en-US" sz="1000">
+                          <a:solidFill>
+                            <a:srgbClr val="000000"/>
+                          </a:solidFill>
+                          <a:latin typeface="Times New Roman"/>
+                        </a:rPr>
+                        <a:t>248,933</a:t>
+                      </a:r>
+                      <a:br/>
+                      <a:r>
+                        <a:rPr lang="en-US" sz="820">
+                          <a:solidFill>
+                            <a:srgbClr val="006F78"/>
+                          </a:solidFill>
+                          <a:latin typeface="Times New Roman"/>
+                        </a:rPr>
+                        <a:t>24.89 Cr</a:t>
+                      </a:r>
+                    </a:p>
+                  </a:txBody>
+                  <a:tcPr marL="12000" marR="12000" marT="8000" marB="8000">
+                    <a:lnL w="12700">
+                      <a:solidFill>
+                        <a:srgbClr val="000000"/>
+                      </a:solidFill>
+                    </a:lnL>
+                    <a:lnR w="12700">
+                      <a:solidFill>
+                        <a:srgbClr val="000000"/>
+                      </a:solidFill>
+                    </a:lnR>
+                    <a:lnT w="12700">
+                      <a:solidFill>
+                        <a:srgbClr val="000000"/>
+                      </a:solidFill>
+                    </a:lnT>
+                    <a:lnB w="12700">
+                      <a:solidFill>
+                        <a:srgbClr val="000000"/>
+                      </a:solidFill>
+                    </a:lnB>
+                    <a:solidFill>
+                      <a:srgbClr val="FFFFFF"/>
+                    </a:solidFill>
+                  </a:tcPr>
+                </a:tc>
+                <a:tc>
+                  <a:txBody>
+                    <a:bodyPr wrap="square" anchor="ctr" lIns="18000" rIns="18000" tIns="10000" bIns="10000"/>
+                    <a:lstStyle/>
+                    <a:p>
+                      <a:pPr algn="ctr"/>
+                      <a:r>
+                        <a:rPr lang="en-US" sz="1000" b="1">
+                          <a:solidFill>
+                            <a:srgbClr val="000000"/>
+                          </a:solidFill>
+                          <a:latin typeface="Times New Roman"/>
+                        </a:rPr>
                         <a:t>53</a:t>
                       </a:r>
-                      <a:br/>
-                      <a:r>
-                        <a:rPr lang="en-US" sz="820">
-                          <a:solidFill>
-                            <a:srgbClr val="006F78"/>
-                          </a:solidFill>
-                          <a:latin typeface="Times New Roman"/>
-                        </a:rPr>
-                        <a:t>0.01 Cr</a:t>
-                      </a:r>
-                    </a:p>
-                  </a:txBody>
-                  <a:tcPr marL="12000" marR="12000" marT="8000" marB="8000">
-                    <a:lnL w="12700">
-                      <a:solidFill>
-                        <a:srgbClr val="000000"/>
-                      </a:solidFill>
-                    </a:lnL>
-                    <a:lnR w="12700">
-                      <a:solidFill>
-                        <a:srgbClr val="000000"/>
-                      </a:solidFill>
-                    </a:lnR>
-                    <a:lnT w="12700">
-                      <a:solidFill>
-                        <a:srgbClr val="000000"/>
-                      </a:solidFill>
-                    </a:lnT>
-                    <a:lnB w="12700">
-                      <a:solidFill>
-                        <a:srgbClr val="000000"/>
-                      </a:solidFill>
-                    </a:lnB>
-                    <a:solidFill>
-                      <a:srgbClr val="FFFFFF"/>
-                    </a:solidFill>
-                  </a:tcPr>
-                </a:tc>
-                <a:tc>
-                  <a:txBody>
-                    <a:bodyPr wrap="square" anchor="ctr" lIns="18000" rIns="18000" tIns="10000" bIns="10000"/>
-                    <a:lstStyle/>
-                    <a:p>
-                      <a:pPr algn="ctr"/>
-                      <a:r>
-                        <a:rPr lang="en-US" sz="1000">
-                          <a:solidFill>
-                            <a:srgbClr val="000000"/>
-                          </a:solidFill>
-                          <a:latin typeface="Times New Roman"/>
-                        </a:rPr>
-                        <a:t>22</a:t>
-                      </a:r>
-                      <a:br/>
-                      <a:r>
-                        <a:rPr lang="en-US" sz="820">
-                          <a:solidFill>
-                            <a:srgbClr val="006F78"/>
-                          </a:solidFill>
-                          <a:latin typeface="Times New Roman"/>
-                        </a:rPr>
-                        <a:t>0.00 Cr</a:t>
-                      </a:r>
-                    </a:p>
-                  </a:txBody>
-                  <a:tcPr marL="12000" marR="12000" marT="8000" marB="8000">
-                    <a:lnL w="12700">
-                      <a:solidFill>
-                        <a:srgbClr val="000000"/>
-                      </a:solidFill>
-                    </a:lnL>
-                    <a:lnR w="12700">
-                      <a:solidFill>
-                        <a:srgbClr val="000000"/>
-                      </a:solidFill>
-                    </a:lnR>
-                    <a:lnT w="12700">
-                      <a:solidFill>
-                        <a:srgbClr val="000000"/>
-                      </a:solidFill>
-                    </a:lnT>
-                    <a:lnB w="12700">
-                      <a:solidFill>
-                        <a:srgbClr val="000000"/>
-                      </a:solidFill>
-                    </a:lnB>
-                    <a:solidFill>
-                      <a:srgbClr val="FFFFFF"/>
-                    </a:solidFill>
-                  </a:tcPr>
-                </a:tc>
-                <a:tc>
-                  <a:txBody>
-                    <a:bodyPr wrap="square" anchor="ctr" lIns="18000" rIns="18000" tIns="10000" bIns="10000"/>
-                    <a:lstStyle/>
-                    <a:p>
-                      <a:pPr algn="ctr"/>
-                      <a:r>
-                        <a:rPr lang="en-US" sz="1000">
-                          <a:solidFill>
-                            <a:srgbClr val="000000"/>
-                          </a:solidFill>
-                          <a:latin typeface="Times New Roman"/>
-                        </a:rPr>
-                        <a:t>278,899</a:t>
-                      </a:r>
-                      <a:br/>
-                      <a:r>
-                        <a:rPr lang="en-US" sz="820">
-                          <a:solidFill>
-                            <a:srgbClr val="006F78"/>
-                          </a:solidFill>
-                          <a:latin typeface="Times New Roman"/>
-                        </a:rPr>
-                        <a:t>27.89 Cr</a:t>
-                      </a:r>
-                    </a:p>
-                  </a:txBody>
-                  <a:tcPr marL="12000" marR="12000" marT="8000" marB="8000">
-                    <a:lnL w="12700">
-                      <a:solidFill>
-                        <a:srgbClr val="000000"/>
-                      </a:solidFill>
-                    </a:lnL>
-                    <a:lnR w="12700">
-                      <a:solidFill>
-                        <a:srgbClr val="000000"/>
-                      </a:solidFill>
-                    </a:lnR>
-                    <a:lnT w="12700">
-                      <a:solidFill>
-                        <a:srgbClr val="000000"/>
-                      </a:solidFill>
-                    </a:lnT>
-                    <a:lnB w="12700">
-                      <a:solidFill>
-                        <a:srgbClr val="000000"/>
-                      </a:solidFill>
-                    </a:lnB>
-                    <a:solidFill>
-                      <a:srgbClr val="FFFFFF"/>
-                    </a:solidFill>
-                  </a:tcPr>
-                </a:tc>
-                <a:tc>
-                  <a:txBody>
-                    <a:bodyPr wrap="square" anchor="ctr" lIns="18000" rIns="18000" tIns="10000" bIns="10000"/>
-                    <a:lstStyle/>
-                    <a:p>
-                      <a:pPr algn="ctr"/>
-                      <a:r>
-                        <a:rPr lang="en-US" sz="1000">
-                          <a:solidFill>
-                            <a:srgbClr val="000000"/>
-                          </a:solidFill>
-                          <a:latin typeface="Times New Roman"/>
-                        </a:rPr>
-                        <a:t>278,877</a:t>
-                      </a:r>
-                      <a:br/>
-                      <a:r>
-                        <a:rPr lang="en-US" sz="820">
-                          <a:solidFill>
-                            <a:srgbClr val="006F78"/>
-                          </a:solidFill>
-                          <a:latin typeface="Times New Roman"/>
-                        </a:rPr>
-                        <a:t>27.89 Cr</a:t>
-                      </a:r>
-                    </a:p>
-                  </a:txBody>
-                  <a:tcPr marL="12000" marR="12000" marT="8000" marB="8000">
-                    <a:lnL w="12700">
-                      <a:solidFill>
-                        <a:srgbClr val="000000"/>
-                      </a:solidFill>
-                    </a:lnL>
-                    <a:lnR w="12700">
-                      <a:solidFill>
-                        <a:srgbClr val="000000"/>
-                      </a:solidFill>
-                    </a:lnR>
-                    <a:lnT w="12700">
-                      <a:solidFill>
-                        <a:srgbClr val="000000"/>
-                      </a:solidFill>
-                    </a:lnT>
-                    <a:lnB w="12700">
-                      <a:solidFill>
-                        <a:srgbClr val="000000"/>
-                      </a:solidFill>
-                    </a:lnB>
-                    <a:solidFill>
-                      <a:srgbClr val="FFFFFF"/>
-                    </a:solidFill>
-                  </a:tcPr>
-                </a:tc>
-                <a:tc>
-                  <a:txBody>
-                    <a:bodyPr wrap="square" anchor="ctr" lIns="18000" rIns="18000" tIns="10000" bIns="10000"/>
-                    <a:lstStyle/>
-                    <a:p>
-                      <a:pPr algn="ctr"/>
-                      <a:r>
-                        <a:rPr lang="en-US" sz="1000" b="1">
-                          <a:solidFill>
-                            <a:srgbClr val="000000"/>
-                          </a:solidFill>
-                          <a:latin typeface="Times New Roman"/>
-                        </a:rPr>
-                        <a:t>1262939</a:t>
-                      </a:r>
-                    </a:p>
-                  </a:txBody>
-                  <a:tcPr marL="12000" marR="12000" marT="8000" marB="8000">
-                    <a:lnL w="12700">
-                      <a:solidFill>
-                        <a:srgbClr val="000000"/>
-                      </a:solidFill>
-                    </a:lnL>
-                    <a:lnR w="12700">
-                      <a:solidFill>
-                        <a:srgbClr val="000000"/>
-                      </a:solidFill>
-                    </a:lnR>
-                    <a:lnT w="12700">
-                      <a:solidFill>
-                        <a:srgbClr val="000000"/>
-                      </a:solidFill>
-                    </a:lnT>
-                    <a:lnB w="12700">
-                      <a:solidFill>
-                        <a:srgbClr val="000000"/>
-                      </a:solidFill>
-                    </a:lnB>
-                    <a:solidFill>
-                      <a:srgbClr val="FCE4E4"/>
-                    </a:solidFill>
-                  </a:tcPr>
-                </a:tc>
-                <a:tc>
-                  <a:txBody>
-                    <a:bodyPr wrap="square" anchor="ctr" lIns="18000" rIns="18000" tIns="10000" bIns="10000"/>
-                    <a:lstStyle/>
-                    <a:p>
-                      <a:pPr algn="ctr"/>
-                      <a:r>
-                        <a:rPr lang="en-US" sz="1000">
-                          <a:solidFill>
-                            <a:srgbClr val="000000"/>
-                          </a:solidFill>
-                          <a:latin typeface="Times New Roman"/>
-                        </a:rPr>
-                        <a:t>-278,846</a:t>
-                      </a:r>
-                      <a:br/>
-                      <a:r>
-                        <a:rPr lang="en-US" sz="820">
-                          <a:solidFill>
-                            <a:srgbClr val="006F78"/>
-                          </a:solidFill>
-                          <a:latin typeface="Times New Roman"/>
-                        </a:rPr>
-                        <a:t>-27.88 Cr</a:t>
-                      </a:r>
-                    </a:p>
-                  </a:txBody>
-                  <a:tcPr marL="12000" marR="12000" marT="8000" marB="8000">
-                    <a:lnL w="12700">
-                      <a:solidFill>
-                        <a:srgbClr val="000000"/>
-                      </a:solidFill>
-                    </a:lnL>
-                    <a:lnR w="12700">
-                      <a:solidFill>
-                        <a:srgbClr val="000000"/>
-                      </a:solidFill>
-                    </a:lnR>
-                    <a:lnT w="12700">
-                      <a:solidFill>
-                        <a:srgbClr val="000000"/>
-                      </a:solidFill>
-                    </a:lnT>
-                    <a:lnB w="12700">
-                      <a:solidFill>
-                        <a:srgbClr val="000000"/>
-                      </a:solidFill>
-                    </a:lnB>
-                    <a:solidFill>
-                      <a:srgbClr val="FFFFFF"/>
-                    </a:solidFill>
-                  </a:tcPr>
-                </a:tc>
-                <a:tc>
-                  <a:txBody>
-                    <a:bodyPr wrap="square" anchor="ctr" lIns="18000" rIns="18000" tIns="10000" bIns="10000"/>
-                    <a:lstStyle/>
-                    <a:p>
-                      <a:pPr algn="ctr"/>
-                      <a:r>
-                        <a:rPr lang="en-US" sz="1000" b="1">
-                          <a:solidFill>
-                            <a:srgbClr val="000000"/>
-                          </a:solidFill>
-                          <a:latin typeface="Times New Roman"/>
-                        </a:rPr>
-                        <a:t>526225</a:t>
-                      </a:r>
-                    </a:p>
-                  </a:txBody>
-                  <a:tcPr marL="12000" marR="12000" marT="8000" marB="8000">
-                    <a:lnL w="12700">
-                      <a:solidFill>
-                        <a:srgbClr val="000000"/>
-                      </a:solidFill>
-                    </a:lnL>
-                    <a:lnR w="12700">
-                      <a:solidFill>
-                        <a:srgbClr val="000000"/>
-                      </a:solidFill>
-                    </a:lnR>
-                    <a:lnT w="12700">
-                      <a:solidFill>
-                        <a:srgbClr val="000000"/>
-                      </a:solidFill>
-                    </a:lnT>
-                    <a:lnB w="12700">
-                      <a:solidFill>
-                        <a:srgbClr val="000000"/>
-                      </a:solidFill>
-                    </a:lnB>
-                    <a:solidFill>
-                      <a:srgbClr val="FCE4E4"/>
+                    </a:p>
+                  </a:txBody>
+                  <a:tcPr marL="12000" marR="12000" marT="8000" marB="8000">
+                    <a:lnL w="12700">
+                      <a:solidFill>
+                        <a:srgbClr val="000000"/>
+                      </a:solidFill>
+                    </a:lnL>
+                    <a:lnR w="12700">
+                      <a:solidFill>
+                        <a:srgbClr val="000000"/>
+                      </a:solidFill>
+                    </a:lnR>
+                    <a:lnT w="12700">
+                      <a:solidFill>
+                        <a:srgbClr val="000000"/>
+                      </a:solidFill>
+                    </a:lnT>
+                    <a:lnB w="12700">
+                      <a:solidFill>
+                        <a:srgbClr val="000000"/>
+                      </a:solidFill>
+                    </a:lnB>
+                    <a:solidFill>
+                      <a:srgbClr val="DFF3E7"/>
                     </a:solidFill>
                   </a:tcPr>
                 </a:tc>
@@ -17981,7 +17981,7 @@
                           </a:solidFill>
                           <a:latin typeface="Times New Roman"/>
                         </a:rPr>
-                        <a:t>2</a:t>
+                        <a:t>16,048</a:t>
                       </a:r>
                       <a:br/>
                       <a:r>
@@ -17991,7 +17991,7 @@
                           </a:solidFill>
                           <a:latin typeface="Times New Roman"/>
                         </a:rPr>
-                        <a:t>0.00 Cr</a:t>
+                        <a:t>1.60 Cr</a:t>
                       </a:r>
                     </a:p>
                   </a:txBody>
@@ -18034,7 +18034,7 @@
                           </a:solidFill>
                           <a:latin typeface="Times New Roman"/>
                         </a:rPr>
-                        <a:t>1</a:t>
+                        <a:t>6,687</a:t>
                       </a:r>
                       <a:br/>
                       <a:r>
@@ -18044,7 +18044,7 @@
                           </a:solidFill>
                           <a:latin typeface="Times New Roman"/>
                         </a:rPr>
-                        <a:t>0.00 Cr</a:t>
+                        <a:t>0.67 Cr</a:t>
                       </a:r>
                     </a:p>
                   </a:txBody>
@@ -18140,7 +18140,7 @@
                           </a:solidFill>
                           <a:latin typeface="Times New Roman"/>
                         </a:rPr>
-                        <a:t>11,131</a:t>
+                        <a:t>4,445</a:t>
                       </a:r>
                       <a:br/>
                       <a:r>
@@ -18150,7 +18150,7 @@
                           </a:solidFill>
                           <a:latin typeface="Times New Roman"/>
                         </a:rPr>
-                        <a:t>1.11 Cr</a:t>
+                        <a:t>0.44 Cr</a:t>
                       </a:r>
                     </a:p>
                   </a:txBody>
@@ -18193,7 +18193,7 @@
                           </a:solidFill>
                           <a:latin typeface="Times New Roman"/>
                         </a:rPr>
-                        <a:t>1335840</a:t>
+                        <a:t>166</a:t>
                       </a:r>
                     </a:p>
                   </a:txBody>
@@ -18236,7 +18236,7 @@
                           </a:solidFill>
                           <a:latin typeface="Times New Roman"/>
                         </a:rPr>
-                        <a:t>-11,130</a:t>
+                        <a:t>4,916</a:t>
                       </a:r>
                       <a:br/>
                       <a:r>
@@ -18246,7 +18246,7 @@
                           </a:solidFill>
                           <a:latin typeface="Times New Roman"/>
                         </a:rPr>
-                        <a:t>-1.11 Cr</a:t>
+                        <a:t>0.49 Cr</a:t>
                       </a:r>
                     </a:p>
                   </a:txBody>
@@ -18289,33 +18289,33 @@
                           </a:solidFill>
                           <a:latin typeface="Times New Roman"/>
                         </a:rPr>
-                        <a:t>556600</a:t>
-                      </a:r>
-                    </a:p>
-                  </a:txBody>
-                  <a:tcPr marL="12000" marR="12000" marT="8000" marB="8000">
-                    <a:lnL w="12700">
-                      <a:solidFill>
-                        <a:srgbClr val="000000"/>
-                      </a:solidFill>
-                    </a:lnL>
-                    <a:lnR w="12700">
-                      <a:solidFill>
-                        <a:srgbClr val="000000"/>
-                      </a:solidFill>
-                    </a:lnR>
-                    <a:lnT w="12700">
-                      <a:solidFill>
-                        <a:srgbClr val="000000"/>
-                      </a:solidFill>
-                    </a:lnT>
-                    <a:lnB w="12700">
-                      <a:solidFill>
-                        <a:srgbClr val="000000"/>
-                      </a:solidFill>
-                    </a:lnB>
-                    <a:solidFill>
-                      <a:srgbClr val="FCE4E4"/>
+                        <a:t>69</a:t>
+                      </a:r>
+                    </a:p>
+                  </a:txBody>
+                  <a:tcPr marL="12000" marR="12000" marT="8000" marB="8000">
+                    <a:lnL w="12700">
+                      <a:solidFill>
+                        <a:srgbClr val="000000"/>
+                      </a:solidFill>
+                    </a:lnL>
+                    <a:lnR w="12700">
+                      <a:solidFill>
+                        <a:srgbClr val="000000"/>
+                      </a:solidFill>
+                    </a:lnR>
+                    <a:lnT w="12700">
+                      <a:solidFill>
+                        <a:srgbClr val="000000"/>
+                      </a:solidFill>
+                    </a:lnT>
+                    <a:lnB w="12700">
+                      <a:solidFill>
+                        <a:srgbClr val="000000"/>
+                      </a:solidFill>
+                    </a:lnB>
+                    <a:solidFill>
+                      <a:srgbClr val="DFF3E7"/>
                     </a:solidFill>
                   </a:tcPr>
                 </a:tc>
@@ -18430,7 +18430,7 @@
                           </a:solidFill>
                           <a:latin typeface="Times New Roman"/>
                         </a:rPr>
-                        <a:t>31</a:t>
+                        <a:t>308,081</a:t>
                       </a:r>
                       <a:br/>
                       <a:r>
@@ -18440,7 +18440,7 @@
                           </a:solidFill>
                           <a:latin typeface="Times New Roman"/>
                         </a:rPr>
-                        <a:t>0.00 Cr</a:t>
+                        <a:t>30.81 Cr</a:t>
                       </a:r>
                     </a:p>
                   </a:txBody>
@@ -18483,7 +18483,7 @@
                           </a:solidFill>
                           <a:latin typeface="Times New Roman"/>
                         </a:rPr>
-                        <a:t>13</a:t>
+                        <a:t>128,367</a:t>
                       </a:r>
                       <a:br/>
                       <a:r>
@@ -18493,7 +18493,7 @@
                           </a:solidFill>
                           <a:latin typeface="Times New Roman"/>
                         </a:rPr>
-                        <a:t>0.00 Cr</a:t>
+                        <a:t>12.84 Cr</a:t>
                       </a:r>
                     </a:p>
                   </a:txBody>
@@ -18589,7 +18589,7 @@
                           </a:solidFill>
                           <a:latin typeface="Times New Roman"/>
                         </a:rPr>
-                        <a:t>217,087</a:t>
+                        <a:t>88,733</a:t>
                       </a:r>
                       <a:br/>
                       <a:r>
@@ -18599,7 +18599,7 @@
                           </a:solidFill>
                           <a:latin typeface="Times New Roman"/>
                         </a:rPr>
-                        <a:t>21.71 Cr</a:t>
+                        <a:t>8.87 Cr</a:t>
                       </a:r>
                     </a:p>
                   </a:txBody>
@@ -18642,7 +18642,7 @@
                           </a:solidFill>
                           <a:latin typeface="Times New Roman"/>
                         </a:rPr>
-                        <a:t>1680774</a:t>
+                        <a:t>169</a:t>
                       </a:r>
                     </a:p>
                   </a:txBody>
@@ -18685,7 +18685,7 @@
                           </a:solidFill>
                           <a:latin typeface="Times New Roman"/>
                         </a:rPr>
-                        <a:t>-217,069</a:t>
+                        <a:t>90,981</a:t>
                       </a:r>
                       <a:br/>
                       <a:r>
@@ -18695,7 +18695,7 @@
                           </a:solidFill>
                           <a:latin typeface="Times New Roman"/>
                         </a:rPr>
-                        <a:t>-21.71 Cr</a:t>
+                        <a:t>9.10 Cr</a:t>
                       </a:r>
                     </a:p>
                   </a:txBody>
@@ -18738,33 +18738,33 @@
                           </a:solidFill>
                           <a:latin typeface="Times New Roman"/>
                         </a:rPr>
-                        <a:t>700323</a:t>
-                      </a:r>
-                    </a:p>
-                  </a:txBody>
-                  <a:tcPr marL="12000" marR="12000" marT="8000" marB="8000">
-                    <a:lnL w="12700">
-                      <a:solidFill>
-                        <a:srgbClr val="000000"/>
-                      </a:solidFill>
-                    </a:lnL>
-                    <a:lnR w="12700">
-                      <a:solidFill>
-                        <a:srgbClr val="000000"/>
-                      </a:solidFill>
-                    </a:lnR>
-                    <a:lnT w="12700">
-                      <a:solidFill>
-                        <a:srgbClr val="000000"/>
-                      </a:solidFill>
-                    </a:lnT>
-                    <a:lnB w="12700">
-                      <a:solidFill>
-                        <a:srgbClr val="000000"/>
-                      </a:solidFill>
-                    </a:lnB>
-                    <a:solidFill>
-                      <a:srgbClr val="FCE4E4"/>
+                        <a:t>70</a:t>
+                      </a:r>
+                    </a:p>
+                  </a:txBody>
+                  <a:tcPr marL="12000" marR="12000" marT="8000" marB="8000">
+                    <a:lnL w="12700">
+                      <a:solidFill>
+                        <a:srgbClr val="000000"/>
+                      </a:solidFill>
+                    </a:lnL>
+                    <a:lnR w="12700">
+                      <a:solidFill>
+                        <a:srgbClr val="000000"/>
+                      </a:solidFill>
+                    </a:lnR>
+                    <a:lnT w="12700">
+                      <a:solidFill>
+                        <a:srgbClr val="000000"/>
+                      </a:solidFill>
+                    </a:lnT>
+                    <a:lnB w="12700">
+                      <a:solidFill>
+                        <a:srgbClr val="000000"/>
+                      </a:solidFill>
+                    </a:lnB>
+                    <a:solidFill>
+                      <a:srgbClr val="DFF3E7"/>
                     </a:solidFill>
                   </a:tcPr>
                 </a:tc>
@@ -18879,7 +18879,7 @@
                           </a:solidFill>
                           <a:latin typeface="Times New Roman"/>
                         </a:rPr>
-                        <a:t>38</a:t>
+                        <a:t>379,418</a:t>
                       </a:r>
                       <a:br/>
                       <a:r>
@@ -18889,7 +18889,7 @@
                           </a:solidFill>
                           <a:latin typeface="Times New Roman"/>
                         </a:rPr>
-                        <a:t>0.00 Cr</a:t>
+                        <a:t>37.94 Cr</a:t>
                       </a:r>
                     </a:p>
                   </a:txBody>
@@ -18932,7 +18932,7 @@
                           </a:solidFill>
                           <a:latin typeface="Times New Roman"/>
                         </a:rPr>
-                        <a:t>16</a:t>
+                        <a:t>158,091</a:t>
                       </a:r>
                       <a:br/>
                       <a:r>
@@ -18942,7 +18942,7 @@
                           </a:solidFill>
                           <a:latin typeface="Times New Roman"/>
                         </a:rPr>
-                        <a:t>0.00 Cr</a:t>
+                        <a:t>15.81 Cr</a:t>
                       </a:r>
                     </a:p>
                   </a:txBody>
@@ -19038,7 +19038,7 @@
                           </a:solidFill>
                           <a:latin typeface="Times New Roman"/>
                         </a:rPr>
-                        <a:t>374,995</a:t>
+                        <a:t>216,920</a:t>
                       </a:r>
                       <a:br/>
                       <a:r>
@@ -19048,7 +19048,7 @@
                           </a:solidFill>
                           <a:latin typeface="Times New Roman"/>
                         </a:rPr>
-                        <a:t>37.50 Cr</a:t>
+                        <a:t>21.69 Cr</a:t>
                       </a:r>
                     </a:p>
                   </a:txBody>
@@ -19091,7 +19091,7 @@
                           </a:solidFill>
                           <a:latin typeface="Times New Roman"/>
                         </a:rPr>
-                        <a:t>2368491</a:t>
+                        <a:t>237</a:t>
                       </a:r>
                     </a:p>
                   </a:txBody>
@@ -19134,7 +19134,7 @@
                           </a:solidFill>
                           <a:latin typeface="Times New Roman"/>
                         </a:rPr>
-                        <a:t>-374,973</a:t>
+                        <a:t>4,407</a:t>
                       </a:r>
                       <a:br/>
                       <a:r>
@@ -19144,7 +19144,7 @@
                           </a:solidFill>
                           <a:latin typeface="Times New Roman"/>
                         </a:rPr>
-                        <a:t>-37.50 Cr</a:t>
+                        <a:t>0.44 Cr</a:t>
                       </a:r>
                     </a:p>
                   </a:txBody>
@@ -19187,33 +19187,33 @@
                           </a:solidFill>
                           <a:latin typeface="Times New Roman"/>
                         </a:rPr>
-                        <a:t>986871</a:t>
-                      </a:r>
-                    </a:p>
-                  </a:txBody>
-                  <a:tcPr marL="12000" marR="12000" marT="8000" marB="8000">
-                    <a:lnL w="12700">
-                      <a:solidFill>
-                        <a:srgbClr val="000000"/>
-                      </a:solidFill>
-                    </a:lnL>
-                    <a:lnR w="12700">
-                      <a:solidFill>
-                        <a:srgbClr val="000000"/>
-                      </a:solidFill>
-                    </a:lnR>
-                    <a:lnT w="12700">
-                      <a:solidFill>
-                        <a:srgbClr val="000000"/>
-                      </a:solidFill>
-                    </a:lnT>
-                    <a:lnB w="12700">
-                      <a:solidFill>
-                        <a:srgbClr val="000000"/>
-                      </a:solidFill>
-                    </a:lnB>
-                    <a:solidFill>
-                      <a:srgbClr val="FCE4E4"/>
+                        <a:t>99</a:t>
+                      </a:r>
+                    </a:p>
+                  </a:txBody>
+                  <a:tcPr marL="12000" marR="12000" marT="8000" marB="8000">
+                    <a:lnL w="12700">
+                      <a:solidFill>
+                        <a:srgbClr val="000000"/>
+                      </a:solidFill>
+                    </a:lnL>
+                    <a:lnR w="12700">
+                      <a:solidFill>
+                        <a:srgbClr val="000000"/>
+                      </a:solidFill>
+                    </a:lnR>
+                    <a:lnT w="12700">
+                      <a:solidFill>
+                        <a:srgbClr val="000000"/>
+                      </a:solidFill>
+                    </a:lnT>
+                    <a:lnB w="12700">
+                      <a:solidFill>
+                        <a:srgbClr val="000000"/>
+                      </a:solidFill>
+                    </a:lnB>
+                    <a:solidFill>
+                      <a:srgbClr val="FFF2CC"/>
                     </a:solidFill>
                   </a:tcPr>
                 </a:tc>
@@ -19328,7 +19328,7 @@
                           </a:solidFill>
                           <a:latin typeface="Times New Roman"/>
                         </a:rPr>
-                        <a:t>1,459</a:t>
+                        <a:t>14,563,547</a:t>
                       </a:r>
                       <a:br/>
                       <a:r>
@@ -19338,7 +19338,7 @@
                           </a:solidFill>
                           <a:latin typeface="Times New Roman"/>
                         </a:rPr>
-                        <a:t>0.15 Cr</a:t>
+                        <a:t>1456.35 Cr</a:t>
                       </a:r>
                     </a:p>
                   </a:txBody>
@@ -19381,7 +19381,7 @@
                           </a:solidFill>
                           <a:latin typeface="Times New Roman"/>
                         </a:rPr>
-                        <a:t>608</a:t>
+                        <a:t>6,068,145</a:t>
                       </a:r>
                       <a:br/>
                       <a:r>
@@ -19391,7 +19391,7 @@
                           </a:solidFill>
                           <a:latin typeface="Times New Roman"/>
                         </a:rPr>
-                        <a:t>0.06 Cr</a:t>
+                        <a:t>606.81 Cr</a:t>
                       </a:r>
                     </a:p>
                   </a:txBody>
@@ -19487,7 +19487,7 @@
                           </a:solidFill>
                           <a:latin typeface="Times New Roman"/>
                         </a:rPr>
-                        <a:t>7,020,533</a:t>
+                        <a:t>952,996</a:t>
                       </a:r>
                       <a:br/>
                       <a:r>
@@ -19497,7 +19497,7 @@
                           </a:solidFill>
                           <a:latin typeface="Times New Roman"/>
                         </a:rPr>
-                        <a:t>702.05 Cr</a:t>
+                        <a:t>95.30 Cr</a:t>
                       </a:r>
                     </a:p>
                   </a:txBody>
@@ -19540,7 +19540,7 @@
                           </a:solidFill>
                           <a:latin typeface="Times New Roman"/>
                         </a:rPr>
-                        <a:t>1154951</a:t>
+                        <a:t>116</a:t>
                       </a:r>
                     </a:p>
                   </a:txBody>
@@ -19583,7 +19583,7 @@
                           </a:solidFill>
                           <a:latin typeface="Times New Roman"/>
                         </a:rPr>
-                        <a:t>-7,019,682</a:t>
+                        <a:t>7,542,406</a:t>
                       </a:r>
                       <a:br/>
                       <a:r>
@@ -19593,7 +19593,7 @@
                           </a:solidFill>
                           <a:latin typeface="Times New Roman"/>
                         </a:rPr>
-                        <a:t>-701.97 Cr</a:t>
+                        <a:t>754.24 Cr</a:t>
                       </a:r>
                     </a:p>
                   </a:txBody>
@@ -19636,33 +19636,33 @@
                           </a:solidFill>
                           <a:latin typeface="Times New Roman"/>
                         </a:rPr>
-                        <a:t>481230</a:t>
-                      </a:r>
-                    </a:p>
-                  </a:txBody>
-                  <a:tcPr marL="12000" marR="12000" marT="8000" marB="8000">
-                    <a:lnL w="12700">
-                      <a:solidFill>
-                        <a:srgbClr val="000000"/>
-                      </a:solidFill>
-                    </a:lnL>
-                    <a:lnR w="12700">
-                      <a:solidFill>
-                        <a:srgbClr val="000000"/>
-                      </a:solidFill>
-                    </a:lnR>
-                    <a:lnT w="12700">
-                      <a:solidFill>
-                        <a:srgbClr val="000000"/>
-                      </a:solidFill>
-                    </a:lnT>
-                    <a:lnB w="12700">
-                      <a:solidFill>
-                        <a:srgbClr val="000000"/>
-                      </a:solidFill>
-                    </a:lnB>
-                    <a:solidFill>
-                      <a:srgbClr val="D92323"/>
+                        <a:t>48</a:t>
+                      </a:r>
+                    </a:p>
+                  </a:txBody>
+                  <a:tcPr marL="12000" marR="12000" marT="8000" marB="8000">
+                    <a:lnL w="12700">
+                      <a:solidFill>
+                        <a:srgbClr val="000000"/>
+                      </a:solidFill>
+                    </a:lnL>
+                    <a:lnR w="12700">
+                      <a:solidFill>
+                        <a:srgbClr val="000000"/>
+                      </a:solidFill>
+                    </a:lnR>
+                    <a:lnT w="12700">
+                      <a:solidFill>
+                        <a:srgbClr val="000000"/>
+                      </a:solidFill>
+                    </a:lnT>
+                    <a:lnB w="12700">
+                      <a:solidFill>
+                        <a:srgbClr val="000000"/>
+                      </a:solidFill>
+                    </a:lnB>
+                    <a:solidFill>
+                      <a:srgbClr val="25A55B"/>
                     </a:solidFill>
                   </a:tcPr>
                 </a:tc>
@@ -19780,7 +19780,7 @@
                 </a:solidFill>
                 <a:latin typeface="Times New Roman"/>
               </a:rPr>
-              <a:t>PU Wise - Non-Staff Part 1 - AUG 2026 | uploaded 2026-09-22T17:27:48+05:30</a:t>
+              <a:t>PU Wise - Non-Staff Part 1 - AUG 2026 | uploaded 2026-09-25T10:56:20+05:30</a:t>
             </a:r>
           </a:p>
         </p:txBody>
@@ -20436,7 +20436,7 @@
                           </a:solidFill>
                           <a:latin typeface="Times New Roman"/>
                         </a:rPr>
-                        <a:t>107</a:t>
+                        <a:t>1,068,752</a:t>
                       </a:r>
                       <a:br/>
                       <a:r>
@@ -20446,7 +20446,7 @@
                           </a:solidFill>
                           <a:latin typeface="Times New Roman"/>
                         </a:rPr>
-                        <a:t>0.01 Cr</a:t>
+                        <a:t>106.88 Cr</a:t>
                       </a:r>
                     </a:p>
                   </a:txBody>
@@ -20489,7 +20489,7 @@
                           </a:solidFill>
                           <a:latin typeface="Times New Roman"/>
                         </a:rPr>
-                        <a:t>45</a:t>
+                        <a:t>445,313</a:t>
                       </a:r>
                       <a:br/>
                       <a:r>
@@ -20499,7 +20499,7 @@
                           </a:solidFill>
                           <a:latin typeface="Times New Roman"/>
                         </a:rPr>
-                        <a:t>0.00 Cr</a:t>
+                        <a:t>44.53 Cr</a:t>
                       </a:r>
                     </a:p>
                   </a:txBody>
@@ -20595,7 +20595,7 @@
                           </a:solidFill>
                           <a:latin typeface="Times New Roman"/>
                         </a:rPr>
-                        <a:t>860,094</a:t>
+                        <a:t>414,826</a:t>
                       </a:r>
                       <a:br/>
                       <a:r>
@@ -20605,7 +20605,7 @@
                           </a:solidFill>
                           <a:latin typeface="Times New Roman"/>
                         </a:rPr>
-                        <a:t>86.01 Cr</a:t>
+                        <a:t>41.48 Cr</a:t>
                       </a:r>
                     </a:p>
                   </a:txBody>
@@ -20648,7 +20648,7 @@
                           </a:solidFill>
                           <a:latin typeface="Times New Roman"/>
                         </a:rPr>
-                        <a:t>1929284</a:t>
+                        <a:t>193</a:t>
                       </a:r>
                     </a:p>
                   </a:txBody>
@@ -20691,7 +20691,7 @@
                           </a:solidFill>
                           <a:latin typeface="Times New Roman"/>
                         </a:rPr>
-                        <a:t>-860,032</a:t>
+                        <a:t>208,613</a:t>
                       </a:r>
                       <a:br/>
                       <a:r>
@@ -20701,7 +20701,7 @@
                           </a:solidFill>
                           <a:latin typeface="Times New Roman"/>
                         </a:rPr>
-                        <a:t>-86.00 Cr</a:t>
+                        <a:t>20.86 Cr</a:t>
                       </a:r>
                     </a:p>
                   </a:txBody>
@@ -20744,33 +20744,33 @@
                           </a:solidFill>
                           <a:latin typeface="Times New Roman"/>
                         </a:rPr>
-                        <a:t>803868</a:t>
-                      </a:r>
-                    </a:p>
-                  </a:txBody>
-                  <a:tcPr marL="12000" marR="12000" marT="8000" marB="8000">
-                    <a:lnL w="12700">
-                      <a:solidFill>
-                        <a:srgbClr val="000000"/>
-                      </a:solidFill>
-                    </a:lnL>
-                    <a:lnR w="12700">
-                      <a:solidFill>
-                        <a:srgbClr val="000000"/>
-                      </a:solidFill>
-                    </a:lnR>
-                    <a:lnT w="12700">
-                      <a:solidFill>
-                        <a:srgbClr val="000000"/>
-                      </a:solidFill>
-                    </a:lnT>
-                    <a:lnB w="12700">
-                      <a:solidFill>
-                        <a:srgbClr val="000000"/>
-                      </a:solidFill>
-                    </a:lnB>
-                    <a:solidFill>
-                      <a:srgbClr val="FCE4E4"/>
+                        <a:t>80</a:t>
+                      </a:r>
+                    </a:p>
+                  </a:txBody>
+                  <a:tcPr marL="12000" marR="12000" marT="8000" marB="8000">
+                    <a:lnL w="12700">
+                      <a:solidFill>
+                        <a:srgbClr val="000000"/>
+                      </a:solidFill>
+                    </a:lnL>
+                    <a:lnR w="12700">
+                      <a:solidFill>
+                        <a:srgbClr val="000000"/>
+                      </a:solidFill>
+                    </a:lnR>
+                    <a:lnT w="12700">
+                      <a:solidFill>
+                        <a:srgbClr val="000000"/>
+                      </a:solidFill>
+                    </a:lnT>
+                    <a:lnB w="12700">
+                      <a:solidFill>
+                        <a:srgbClr val="000000"/>
+                      </a:solidFill>
+                    </a:lnB>
+                    <a:solidFill>
+                      <a:srgbClr val="FFF2CC"/>
                     </a:solidFill>
                   </a:tcPr>
                 </a:tc>
@@ -20885,7 +20885,7 @@
                           </a:solidFill>
                           <a:latin typeface="Times New Roman"/>
                         </a:rPr>
-                        <a:t>15</a:t>
+                        <a:t>149,947</a:t>
                       </a:r>
                       <a:br/>
                       <a:r>
@@ -20895,7 +20895,7 @@
                           </a:solidFill>
                           <a:latin typeface="Times New Roman"/>
                         </a:rPr>
-                        <a:t>0.00 Cr</a:t>
+                        <a:t>14.99 Cr</a:t>
                       </a:r>
                     </a:p>
                   </a:txBody>
@@ -20938,7 +20938,7 @@
                           </a:solidFill>
                           <a:latin typeface="Times New Roman"/>
                         </a:rPr>
-                        <a:t>6</a:t>
+                        <a:t>62,478</a:t>
                       </a:r>
                       <a:br/>
                       <a:r>
@@ -20948,7 +20948,7 @@
                           </a:solidFill>
                           <a:latin typeface="Times New Roman"/>
                         </a:rPr>
-                        <a:t>0.00 Cr</a:t>
+                        <a:t>6.25 Cr</a:t>
                       </a:r>
                     </a:p>
                   </a:txBody>
@@ -21044,7 +21044,7 @@
                           </a:solidFill>
                           <a:latin typeface="Times New Roman"/>
                         </a:rPr>
-                        <a:t>70,602</a:t>
+                        <a:t>8,130</a:t>
                       </a:r>
                       <a:br/>
                       <a:r>
@@ -21054,7 +21054,7 @@
                           </a:solidFill>
                           <a:latin typeface="Times New Roman"/>
                         </a:rPr>
-                        <a:t>7.06 Cr</a:t>
+                        <a:t>0.81 Cr</a:t>
                       </a:r>
                     </a:p>
                   </a:txBody>
@@ -21097,7 +21097,7 @@
                           </a:solidFill>
                           <a:latin typeface="Times New Roman"/>
                         </a:rPr>
-                        <a:t>1129728</a:t>
+                        <a:t>113</a:t>
                       </a:r>
                     </a:p>
                   </a:txBody>
@@ -21140,7 +21140,7 @@
                           </a:solidFill>
                           <a:latin typeface="Times New Roman"/>
                         </a:rPr>
-                        <a:t>-70,593</a:t>
+                        <a:t>79,339</a:t>
                       </a:r>
                       <a:br/>
                       <a:r>
@@ -21150,7 +21150,7 @@
                           </a:solidFill>
                           <a:latin typeface="Times New Roman"/>
                         </a:rPr>
-                        <a:t>-7.06 Cr</a:t>
+                        <a:t>7.93 Cr</a:t>
                       </a:r>
                     </a:p>
                   </a:txBody>
@@ -21193,33 +21193,33 @@
                           </a:solidFill>
                           <a:latin typeface="Times New Roman"/>
                         </a:rPr>
-                        <a:t>470720</a:t>
-                      </a:r>
-                    </a:p>
-                  </a:txBody>
-                  <a:tcPr marL="12000" marR="12000" marT="8000" marB="8000">
-                    <a:lnL w="12700">
-                      <a:solidFill>
-                        <a:srgbClr val="000000"/>
-                      </a:solidFill>
-                    </a:lnL>
-                    <a:lnR w="12700">
-                      <a:solidFill>
-                        <a:srgbClr val="000000"/>
-                      </a:solidFill>
-                    </a:lnR>
-                    <a:lnT w="12700">
-                      <a:solidFill>
-                        <a:srgbClr val="000000"/>
-                      </a:solidFill>
-                    </a:lnT>
-                    <a:lnB w="12700">
-                      <a:solidFill>
-                        <a:srgbClr val="000000"/>
-                      </a:solidFill>
-                    </a:lnB>
-                    <a:solidFill>
-                      <a:srgbClr val="FCE4E4"/>
+                        <a:t>47</a:t>
+                      </a:r>
+                    </a:p>
+                  </a:txBody>
+                  <a:tcPr marL="12000" marR="12000" marT="8000" marB="8000">
+                    <a:lnL w="12700">
+                      <a:solidFill>
+                        <a:srgbClr val="000000"/>
+                      </a:solidFill>
+                    </a:lnL>
+                    <a:lnR w="12700">
+                      <a:solidFill>
+                        <a:srgbClr val="000000"/>
+                      </a:solidFill>
+                    </a:lnR>
+                    <a:lnT w="12700">
+                      <a:solidFill>
+                        <a:srgbClr val="000000"/>
+                      </a:solidFill>
+                    </a:lnT>
+                    <a:lnB w="12700">
+                      <a:solidFill>
+                        <a:srgbClr val="000000"/>
+                      </a:solidFill>
+                    </a:lnB>
+                    <a:solidFill>
+                      <a:srgbClr val="DFF3E7"/>
                     </a:solidFill>
                   </a:tcPr>
                 </a:tc>
@@ -21334,7 +21334,7 @@
                           </a:solidFill>
                           <a:latin typeface="Times New Roman"/>
                         </a:rPr>
-                        <a:t>388</a:t>
+                        <a:t>3,878,724</a:t>
                       </a:r>
                       <a:br/>
                       <a:r>
@@ -21344,7 +21344,7 @@
                           </a:solidFill>
                           <a:latin typeface="Times New Roman"/>
                         </a:rPr>
-                        <a:t>0.04 Cr</a:t>
+                        <a:t>387.87 Cr</a:t>
                       </a:r>
                     </a:p>
                   </a:txBody>
@@ -21387,7 +21387,7 @@
                           </a:solidFill>
                           <a:latin typeface="Times New Roman"/>
                         </a:rPr>
-                        <a:t>162</a:t>
+                        <a:t>1,616,135</a:t>
                       </a:r>
                       <a:br/>
                       <a:r>
@@ -21397,7 +21397,7 @@
                           </a:solidFill>
                           <a:latin typeface="Times New Roman"/>
                         </a:rPr>
-                        <a:t>0.02 Cr</a:t>
+                        <a:t>161.61 Cr</a:t>
                       </a:r>
                     </a:p>
                   </a:txBody>
@@ -21493,7 +21493,7 @@
                           </a:solidFill>
                           <a:latin typeface="Times New Roman"/>
                         </a:rPr>
-                        <a:t>1,916,347</a:t>
+                        <a:t>300,374</a:t>
                       </a:r>
                       <a:br/>
                       <a:r>
@@ -21503,7 +21503,7 @@
                           </a:solidFill>
                           <a:latin typeface="Times New Roman"/>
                         </a:rPr>
-                        <a:t>191.63 Cr</a:t>
+                        <a:t>30.04 Cr</a:t>
                       </a:r>
                     </a:p>
                   </a:txBody>
@@ -21546,7 +21546,7 @@
                           </a:solidFill>
                           <a:latin typeface="Times New Roman"/>
                         </a:rPr>
-                        <a:t>1185469</a:t>
+                        <a:t>119</a:t>
                       </a:r>
                     </a:p>
                   </a:txBody>
@@ -21589,7 +21589,7 @@
                           </a:solidFill>
                           <a:latin typeface="Times New Roman"/>
                         </a:rPr>
-                        <a:t>-1,916,121</a:t>
+                        <a:t>1,962,215</a:t>
                       </a:r>
                       <a:br/>
                       <a:r>
@@ -21599,7 +21599,7 @@
                           </a:solidFill>
                           <a:latin typeface="Times New Roman"/>
                         </a:rPr>
-                        <a:t>-191.61 Cr</a:t>
+                        <a:t>196.22 Cr</a:t>
                       </a:r>
                     </a:p>
                   </a:txBody>
@@ -21642,33 +21642,33 @@
                           </a:solidFill>
                           <a:latin typeface="Times New Roman"/>
                         </a:rPr>
-                        <a:t>493946</a:t>
-                      </a:r>
-                    </a:p>
-                  </a:txBody>
-                  <a:tcPr marL="12000" marR="12000" marT="8000" marB="8000">
-                    <a:lnL w="12700">
-                      <a:solidFill>
-                        <a:srgbClr val="000000"/>
-                      </a:solidFill>
-                    </a:lnL>
-                    <a:lnR w="12700">
-                      <a:solidFill>
-                        <a:srgbClr val="000000"/>
-                      </a:solidFill>
-                    </a:lnR>
-                    <a:lnT w="12700">
-                      <a:solidFill>
-                        <a:srgbClr val="000000"/>
-                      </a:solidFill>
-                    </a:lnT>
-                    <a:lnB w="12700">
-                      <a:solidFill>
-                        <a:srgbClr val="000000"/>
-                      </a:solidFill>
-                    </a:lnB>
-                    <a:solidFill>
-                      <a:srgbClr val="FCE4E4"/>
+                        <a:t>49</a:t>
+                      </a:r>
+                    </a:p>
+                  </a:txBody>
+                  <a:tcPr marL="12000" marR="12000" marT="8000" marB="8000">
+                    <a:lnL w="12700">
+                      <a:solidFill>
+                        <a:srgbClr val="000000"/>
+                      </a:solidFill>
+                    </a:lnL>
+                    <a:lnR w="12700">
+                      <a:solidFill>
+                        <a:srgbClr val="000000"/>
+                      </a:solidFill>
+                    </a:lnR>
+                    <a:lnT w="12700">
+                      <a:solidFill>
+                        <a:srgbClr val="000000"/>
+                      </a:solidFill>
+                    </a:lnT>
+                    <a:lnB w="12700">
+                      <a:solidFill>
+                        <a:srgbClr val="000000"/>
+                      </a:solidFill>
+                    </a:lnB>
+                    <a:solidFill>
+                      <a:srgbClr val="DFF3E7"/>
                     </a:solidFill>
                   </a:tcPr>
                 </a:tc>
@@ -21783,7 +21783,7 @@
                           </a:solidFill>
                           <a:latin typeface="Times New Roman"/>
                         </a:rPr>
-                        <a:t>325</a:t>
+                        <a:t>3,254,310</a:t>
                       </a:r>
                       <a:br/>
                       <a:r>
@@ -21793,7 +21793,7 @@
                           </a:solidFill>
                           <a:latin typeface="Times New Roman"/>
                         </a:rPr>
-                        <a:t>0.03 Cr</a:t>
+                        <a:t>325.43 Cr</a:t>
                       </a:r>
                     </a:p>
                   </a:txBody>
@@ -21836,8 +21836,210 @@
                           </a:solidFill>
                           <a:latin typeface="Times New Roman"/>
                         </a:rPr>
+                        <a:t>1,355,962</a:t>
+                      </a:r>
+                      <a:br/>
+                      <a:r>
+                        <a:rPr lang="en-US" sz="820">
+                          <a:solidFill>
+                            <a:srgbClr val="006F78"/>
+                          </a:solidFill>
+                          <a:latin typeface="Times New Roman"/>
+                        </a:rPr>
+                        <a:t>135.60 Cr</a:t>
+                      </a:r>
+                    </a:p>
+                  </a:txBody>
+                  <a:tcPr marL="12000" marR="12000" marT="8000" marB="8000">
+                    <a:lnL w="12700">
+                      <a:solidFill>
+                        <a:srgbClr val="000000"/>
+                      </a:solidFill>
+                    </a:lnL>
+                    <a:lnR w="12700">
+                      <a:solidFill>
+                        <a:srgbClr val="000000"/>
+                      </a:solidFill>
+                    </a:lnR>
+                    <a:lnT w="12700">
+                      <a:solidFill>
+                        <a:srgbClr val="000000"/>
+                      </a:solidFill>
+                    </a:lnT>
+                    <a:lnB w="12700">
+                      <a:solidFill>
+                        <a:srgbClr val="000000"/>
+                      </a:solidFill>
+                    </a:lnB>
+                    <a:solidFill>
+                      <a:srgbClr val="D9EAF7"/>
+                    </a:solidFill>
+                  </a:tcPr>
+                </a:tc>
+                <a:tc>
+                  <a:txBody>
+                    <a:bodyPr wrap="square" anchor="ctr" lIns="18000" rIns="18000" tIns="10000" bIns="10000"/>
+                    <a:lstStyle/>
+                    <a:p>
+                      <a:pPr algn="ctr"/>
+                      <a:r>
+                        <a:rPr lang="en-US" sz="1000">
+                          <a:solidFill>
+                            <a:srgbClr val="000000"/>
+                          </a:solidFill>
+                          <a:latin typeface="Times New Roman"/>
+                        </a:rPr>
+                        <a:t>1,824,117</a:t>
+                      </a:r>
+                      <a:br/>
+                      <a:r>
+                        <a:rPr lang="en-US" sz="820">
+                          <a:solidFill>
+                            <a:srgbClr val="006F78"/>
+                          </a:solidFill>
+                          <a:latin typeface="Times New Roman"/>
+                        </a:rPr>
+                        <a:t>182.41 Cr</a:t>
+                      </a:r>
+                    </a:p>
+                  </a:txBody>
+                  <a:tcPr marL="12000" marR="12000" marT="8000" marB="8000">
+                    <a:lnL w="12700">
+                      <a:solidFill>
+                        <a:srgbClr val="000000"/>
+                      </a:solidFill>
+                    </a:lnL>
+                    <a:lnR w="12700">
+                      <a:solidFill>
+                        <a:srgbClr val="000000"/>
+                      </a:solidFill>
+                    </a:lnR>
+                    <a:lnT w="12700">
+                      <a:solidFill>
+                        <a:srgbClr val="000000"/>
+                      </a:solidFill>
+                    </a:lnT>
+                    <a:lnB w="12700">
+                      <a:solidFill>
+                        <a:srgbClr val="000000"/>
+                      </a:solidFill>
+                    </a:lnB>
+                    <a:solidFill>
+                      <a:srgbClr val="D9EAF7"/>
+                    </a:solidFill>
+                  </a:tcPr>
+                </a:tc>
+                <a:tc>
+                  <a:txBody>
+                    <a:bodyPr wrap="square" anchor="ctr" lIns="18000" rIns="18000" tIns="10000" bIns="10000"/>
+                    <a:lstStyle/>
+                    <a:p>
+                      <a:pPr algn="ctr"/>
+                      <a:r>
+                        <a:rPr lang="en-US" sz="1000">
+                          <a:solidFill>
+                            <a:srgbClr val="000000"/>
+                          </a:solidFill>
+                          <a:latin typeface="Times New Roman"/>
+                        </a:rPr>
+                        <a:t>468,154</a:t>
+                      </a:r>
+                      <a:br/>
+                      <a:r>
+                        <a:rPr lang="en-US" sz="820">
+                          <a:solidFill>
+                            <a:srgbClr val="006F78"/>
+                          </a:solidFill>
+                          <a:latin typeface="Times New Roman"/>
+                        </a:rPr>
+                        <a:t>46.82 Cr</a:t>
+                      </a:r>
+                    </a:p>
+                  </a:txBody>
+                  <a:tcPr marL="12000" marR="12000" marT="8000" marB="8000">
+                    <a:lnL w="12700">
+                      <a:solidFill>
+                        <a:srgbClr val="000000"/>
+                      </a:solidFill>
+                    </a:lnL>
+                    <a:lnR w="12700">
+                      <a:solidFill>
+                        <a:srgbClr val="000000"/>
+                      </a:solidFill>
+                    </a:lnR>
+                    <a:lnT w="12700">
+                      <a:solidFill>
+                        <a:srgbClr val="000000"/>
+                      </a:solidFill>
+                    </a:lnT>
+                    <a:lnB w="12700">
+                      <a:solidFill>
+                        <a:srgbClr val="000000"/>
+                      </a:solidFill>
+                    </a:lnB>
+                    <a:solidFill>
+                      <a:srgbClr val="D9EAF7"/>
+                    </a:solidFill>
+                  </a:tcPr>
+                </a:tc>
+                <a:tc>
+                  <a:txBody>
+                    <a:bodyPr wrap="square" anchor="ctr" lIns="18000" rIns="18000" tIns="10000" bIns="10000"/>
+                    <a:lstStyle/>
+                    <a:p>
+                      <a:pPr algn="ctr"/>
+                      <a:r>
+                        <a:rPr lang="en-US" sz="1000" b="1">
+                          <a:solidFill>
+                            <a:srgbClr val="000000"/>
+                          </a:solidFill>
+                          <a:latin typeface="Times New Roman"/>
+                        </a:rPr>
                         <a:t>135</a:t>
                       </a:r>
+                    </a:p>
+                  </a:txBody>
+                  <a:tcPr marL="12000" marR="12000" marT="8000" marB="8000">
+                    <a:lnL w="12700">
+                      <a:solidFill>
+                        <a:srgbClr val="000000"/>
+                      </a:solidFill>
+                    </a:lnL>
+                    <a:lnR w="12700">
+                      <a:solidFill>
+                        <a:srgbClr val="000000"/>
+                      </a:solidFill>
+                    </a:lnR>
+                    <a:lnT w="12700">
+                      <a:solidFill>
+                        <a:srgbClr val="000000"/>
+                      </a:solidFill>
+                    </a:lnT>
+                    <a:lnB w="12700">
+                      <a:solidFill>
+                        <a:srgbClr val="000000"/>
+                      </a:solidFill>
+                    </a:lnB>
+                    <a:solidFill>
+                      <a:srgbClr val="FCE4E4"/>
+                    </a:solidFill>
+                  </a:tcPr>
+                </a:tc>
+                <a:tc>
+                  <a:txBody>
+                    <a:bodyPr wrap="square" anchor="ctr" lIns="18000" rIns="18000" tIns="10000" bIns="10000"/>
+                    <a:lstStyle/>
+                    <a:p>
+                      <a:pPr algn="ctr"/>
+                      <a:r>
+                        <a:rPr lang="en-US" sz="1000">
+                          <a:solidFill>
+                            <a:srgbClr val="000000"/>
+                          </a:solidFill>
+                          <a:latin typeface="Times New Roman"/>
+                        </a:rPr>
+                        <a:t>1,430,193</a:t>
+                      </a:r>
                       <a:br/>
                       <a:r>
                         <a:rPr lang="en-US" sz="820">
@@ -21846,7 +22048,7 @@
                           </a:solidFill>
                           <a:latin typeface="Times New Roman"/>
                         </a:rPr>
-                        <a:t>0.01 Cr</a:t>
+                        <a:t>143.02 Cr</a:t>
                       </a:r>
                     </a:p>
                   </a:txBody>
@@ -21883,241 +22085,39 @@
                     <a:p>
                       <a:pPr algn="ctr"/>
                       <a:r>
-                        <a:rPr lang="en-US" sz="1000">
-                          <a:solidFill>
-                            <a:srgbClr val="000000"/>
-                          </a:solidFill>
-                          <a:latin typeface="Times New Roman"/>
-                        </a:rPr>
-                        <a:t>1,824,117</a:t>
-                      </a:r>
-                      <a:br/>
-                      <a:r>
-                        <a:rPr lang="en-US" sz="820">
-                          <a:solidFill>
-                            <a:srgbClr val="006F78"/>
-                          </a:solidFill>
-                          <a:latin typeface="Times New Roman"/>
-                        </a:rPr>
-                        <a:t>182.41 Cr</a:t>
-                      </a:r>
-                    </a:p>
-                  </a:txBody>
-                  <a:tcPr marL="12000" marR="12000" marT="8000" marB="8000">
-                    <a:lnL w="12700">
-                      <a:solidFill>
-                        <a:srgbClr val="000000"/>
-                      </a:solidFill>
-                    </a:lnL>
-                    <a:lnR w="12700">
-                      <a:solidFill>
-                        <a:srgbClr val="000000"/>
-                      </a:solidFill>
-                    </a:lnR>
-                    <a:lnT w="12700">
-                      <a:solidFill>
-                        <a:srgbClr val="000000"/>
-                      </a:solidFill>
-                    </a:lnT>
-                    <a:lnB w="12700">
-                      <a:solidFill>
-                        <a:srgbClr val="000000"/>
-                      </a:solidFill>
-                    </a:lnB>
-                    <a:solidFill>
-                      <a:srgbClr val="D9EAF7"/>
-                    </a:solidFill>
-                  </a:tcPr>
-                </a:tc>
-                <a:tc>
-                  <a:txBody>
-                    <a:bodyPr wrap="square" anchor="ctr" lIns="18000" rIns="18000" tIns="10000" bIns="10000"/>
-                    <a:lstStyle/>
-                    <a:p>
-                      <a:pPr algn="ctr"/>
-                      <a:r>
-                        <a:rPr lang="en-US" sz="1000">
-                          <a:solidFill>
-                            <a:srgbClr val="000000"/>
-                          </a:solidFill>
-                          <a:latin typeface="Times New Roman"/>
-                        </a:rPr>
-                        <a:t>1,823,982</a:t>
-                      </a:r>
-                      <a:br/>
-                      <a:r>
-                        <a:rPr lang="en-US" sz="820">
-                          <a:solidFill>
-                            <a:srgbClr val="006F78"/>
-                          </a:solidFill>
-                          <a:latin typeface="Times New Roman"/>
-                        </a:rPr>
-                        <a:t>182.40 Cr</a:t>
-                      </a:r>
-                    </a:p>
-                  </a:txBody>
-                  <a:tcPr marL="12000" marR="12000" marT="8000" marB="8000">
-                    <a:lnL w="12700">
-                      <a:solidFill>
-                        <a:srgbClr val="000000"/>
-                      </a:solidFill>
-                    </a:lnL>
-                    <a:lnR w="12700">
-                      <a:solidFill>
-                        <a:srgbClr val="000000"/>
-                      </a:solidFill>
-                    </a:lnR>
-                    <a:lnT w="12700">
-                      <a:solidFill>
-                        <a:srgbClr val="000000"/>
-                      </a:solidFill>
-                    </a:lnT>
-                    <a:lnB w="12700">
-                      <a:solidFill>
-                        <a:srgbClr val="000000"/>
-                      </a:solidFill>
-                    </a:lnB>
-                    <a:solidFill>
-                      <a:srgbClr val="D9EAF7"/>
-                    </a:solidFill>
-                  </a:tcPr>
-                </a:tc>
-                <a:tc>
-                  <a:txBody>
-                    <a:bodyPr wrap="square" anchor="ctr" lIns="18000" rIns="18000" tIns="10000" bIns="10000"/>
-                    <a:lstStyle/>
-                    <a:p>
-                      <a:pPr algn="ctr"/>
-                      <a:r>
                         <a:rPr lang="en-US" sz="1000" b="1">
                           <a:solidFill>
                             <a:srgbClr val="000000"/>
                           </a:solidFill>
                           <a:latin typeface="Times New Roman"/>
                         </a:rPr>
-                        <a:t>1347040</a:t>
-                      </a:r>
-                    </a:p>
-                  </a:txBody>
-                  <a:tcPr marL="12000" marR="12000" marT="8000" marB="8000">
-                    <a:lnL w="12700">
-                      <a:solidFill>
-                        <a:srgbClr val="000000"/>
-                      </a:solidFill>
-                    </a:lnL>
-                    <a:lnR w="12700">
-                      <a:solidFill>
-                        <a:srgbClr val="000000"/>
-                      </a:solidFill>
-                    </a:lnR>
-                    <a:lnT w="12700">
-                      <a:solidFill>
-                        <a:srgbClr val="000000"/>
-                      </a:solidFill>
-                    </a:lnT>
-                    <a:lnB w="12700">
-                      <a:solidFill>
-                        <a:srgbClr val="000000"/>
-                      </a:solidFill>
-                    </a:lnB>
-                    <a:solidFill>
-                      <a:srgbClr val="FCE4E4"/>
-                    </a:solidFill>
-                  </a:tcPr>
-                </a:tc>
-                <a:tc>
-                  <a:txBody>
-                    <a:bodyPr wrap="square" anchor="ctr" lIns="18000" rIns="18000" tIns="10000" bIns="10000"/>
-                    <a:lstStyle/>
-                    <a:p>
-                      <a:pPr algn="ctr"/>
-                      <a:r>
-                        <a:rPr lang="en-US" sz="1000">
-                          <a:solidFill>
-                            <a:srgbClr val="000000"/>
-                          </a:solidFill>
-                          <a:latin typeface="Times New Roman"/>
-                        </a:rPr>
-                        <a:t>-1,823,792</a:t>
-                      </a:r>
-                      <a:br/>
-                      <a:r>
-                        <a:rPr lang="en-US" sz="820">
-                          <a:solidFill>
-                            <a:srgbClr val="006F78"/>
-                          </a:solidFill>
-                          <a:latin typeface="Times New Roman"/>
-                        </a:rPr>
-                        <a:t>-182.38 Cr</a:t>
-                      </a:r>
-                    </a:p>
-                  </a:txBody>
-                  <a:tcPr marL="12000" marR="12000" marT="8000" marB="8000">
-                    <a:lnL w="12700">
-                      <a:solidFill>
-                        <a:srgbClr val="000000"/>
-                      </a:solidFill>
-                    </a:lnL>
-                    <a:lnR w="12700">
-                      <a:solidFill>
-                        <a:srgbClr val="000000"/>
-                      </a:solidFill>
-                    </a:lnR>
-                    <a:lnT w="12700">
-                      <a:solidFill>
-                        <a:srgbClr val="000000"/>
-                      </a:solidFill>
-                    </a:lnT>
-                    <a:lnB w="12700">
-                      <a:solidFill>
-                        <a:srgbClr val="000000"/>
-                      </a:solidFill>
-                    </a:lnB>
-                    <a:solidFill>
-                      <a:srgbClr val="D9EAF7"/>
-                    </a:solidFill>
-                  </a:tcPr>
-                </a:tc>
-                <a:tc>
-                  <a:txBody>
-                    <a:bodyPr wrap="square" anchor="ctr" lIns="18000" rIns="18000" tIns="10000" bIns="10000"/>
-                    <a:lstStyle/>
-                    <a:p>
-                      <a:pPr algn="ctr"/>
-                      <a:r>
-                        <a:rPr lang="en-US" sz="1000" b="1">
-                          <a:solidFill>
-                            <a:srgbClr val="000000"/>
-                          </a:solidFill>
-                          <a:latin typeface="Times New Roman"/>
-                        </a:rPr>
-                        <a:t>561267</a:t>
-                      </a:r>
-                    </a:p>
-                  </a:txBody>
-                  <a:tcPr marL="12000" marR="12000" marT="8000" marB="8000">
-                    <a:lnL w="12700">
-                      <a:solidFill>
-                        <a:srgbClr val="000000"/>
-                      </a:solidFill>
-                    </a:lnL>
-                    <a:lnR w="12700">
-                      <a:solidFill>
-                        <a:srgbClr val="000000"/>
-                      </a:solidFill>
-                    </a:lnR>
-                    <a:lnT w="12700">
-                      <a:solidFill>
-                        <a:srgbClr val="000000"/>
-                      </a:solidFill>
-                    </a:lnT>
-                    <a:lnB w="12700">
-                      <a:solidFill>
-                        <a:srgbClr val="000000"/>
-                      </a:solidFill>
-                    </a:lnB>
-                    <a:solidFill>
-                      <a:srgbClr val="FCE4E4"/>
+                        <a:t>56</a:t>
+                      </a:r>
+                    </a:p>
+                  </a:txBody>
+                  <a:tcPr marL="12000" marR="12000" marT="8000" marB="8000">
+                    <a:lnL w="12700">
+                      <a:solidFill>
+                        <a:srgbClr val="000000"/>
+                      </a:solidFill>
+                    </a:lnL>
+                    <a:lnR w="12700">
+                      <a:solidFill>
+                        <a:srgbClr val="000000"/>
+                      </a:solidFill>
+                    </a:lnR>
+                    <a:lnT w="12700">
+                      <a:solidFill>
+                        <a:srgbClr val="000000"/>
+                      </a:solidFill>
+                    </a:lnT>
+                    <a:lnB w="12700">
+                      <a:solidFill>
+                        <a:srgbClr val="000000"/>
+                      </a:solidFill>
+                    </a:lnB>
+                    <a:solidFill>
+                      <a:srgbClr val="DFF3E7"/>
                     </a:solidFill>
                   </a:tcPr>
                 </a:tc>
@@ -22232,7 +22232,7 @@
                           </a:solidFill>
                           <a:latin typeface="Times New Roman"/>
                         </a:rPr>
-                        <a:t>470</a:t>
+                        <a:t>4,703,356</a:t>
                       </a:r>
                       <a:br/>
                       <a:r>
@@ -22242,7 +22242,7 @@
                           </a:solidFill>
                           <a:latin typeface="Times New Roman"/>
                         </a:rPr>
-                        <a:t>0.05 Cr</a:t>
+                        <a:t>470.34 Cr</a:t>
                       </a:r>
                     </a:p>
                   </a:txBody>
@@ -22285,7 +22285,7 @@
                           </a:solidFill>
                           <a:latin typeface="Times New Roman"/>
                         </a:rPr>
-                        <a:t>196</a:t>
+                        <a:t>1,959,732</a:t>
                       </a:r>
                       <a:br/>
                       <a:r>
@@ -22295,7 +22295,7 @@
                           </a:solidFill>
                           <a:latin typeface="Times New Roman"/>
                         </a:rPr>
-                        <a:t>0.02 Cr</a:t>
+                        <a:t>195.97 Cr</a:t>
                       </a:r>
                     </a:p>
                   </a:txBody>
@@ -22391,7 +22391,7 @@
                           </a:solidFill>
                           <a:latin typeface="Times New Roman"/>
                         </a:rPr>
-                        <a:t>2,715,219</a:t>
+                        <a:t>755,683</a:t>
                       </a:r>
                       <a:br/>
                       <a:r>
@@ -22401,7 +22401,7 @@
                           </a:solidFill>
                           <a:latin typeface="Times New Roman"/>
                         </a:rPr>
-                        <a:t>271.52 Cr</a:t>
+                        <a:t>75.57 Cr</a:t>
                       </a:r>
                     </a:p>
                   </a:txBody>
@@ -22444,7 +22444,7 @@
                           </a:solidFill>
                           <a:latin typeface="Times New Roman"/>
                         </a:rPr>
-                        <a:t>1386595</a:t>
+                        <a:t>139</a:t>
                       </a:r>
                     </a:p>
                   </a:txBody>
@@ -22487,7 +22487,7 @@
                           </a:solidFill>
                           <a:latin typeface="Times New Roman"/>
                         </a:rPr>
-                        <a:t>-2,714,945</a:t>
+                        <a:t>1,987,941</a:t>
                       </a:r>
                       <a:br/>
                       <a:r>
@@ -22497,7 +22497,7 @@
                           </a:solidFill>
                           <a:latin typeface="Times New Roman"/>
                         </a:rPr>
-                        <a:t>-271.49 Cr</a:t>
+                        <a:t>198.79 Cr</a:t>
                       </a:r>
                     </a:p>
                   </a:txBody>
@@ -22540,33 +22540,33 @@
                           </a:solidFill>
                           <a:latin typeface="Times New Roman"/>
                         </a:rPr>
-                        <a:t>577748</a:t>
-                      </a:r>
-                    </a:p>
-                  </a:txBody>
-                  <a:tcPr marL="12000" marR="12000" marT="8000" marB="8000">
-                    <a:lnL w="12700">
-                      <a:solidFill>
-                        <a:srgbClr val="000000"/>
-                      </a:solidFill>
-                    </a:lnL>
-                    <a:lnR w="12700">
-                      <a:solidFill>
-                        <a:srgbClr val="000000"/>
-                      </a:solidFill>
-                    </a:lnR>
-                    <a:lnT w="12700">
-                      <a:solidFill>
-                        <a:srgbClr val="000000"/>
-                      </a:solidFill>
-                    </a:lnT>
-                    <a:lnB w="12700">
-                      <a:solidFill>
-                        <a:srgbClr val="000000"/>
-                      </a:solidFill>
-                    </a:lnB>
-                    <a:solidFill>
-                      <a:srgbClr val="FCE4E4"/>
+                        <a:t>58</a:t>
+                      </a:r>
+                    </a:p>
+                  </a:txBody>
+                  <a:tcPr marL="12000" marR="12000" marT="8000" marB="8000">
+                    <a:lnL w="12700">
+                      <a:solidFill>
+                        <a:srgbClr val="000000"/>
+                      </a:solidFill>
+                    </a:lnL>
+                    <a:lnR w="12700">
+                      <a:solidFill>
+                        <a:srgbClr val="000000"/>
+                      </a:solidFill>
+                    </a:lnR>
+                    <a:lnT w="12700">
+                      <a:solidFill>
+                        <a:srgbClr val="000000"/>
+                      </a:solidFill>
+                    </a:lnT>
+                    <a:lnB w="12700">
+                      <a:solidFill>
+                        <a:srgbClr val="000000"/>
+                      </a:solidFill>
+                    </a:lnB>
+                    <a:solidFill>
+                      <a:srgbClr val="DFF3E7"/>
                     </a:solidFill>
                   </a:tcPr>
                 </a:tc>
@@ -22681,7 +22681,7 @@
                           </a:solidFill>
                           <a:latin typeface="Times New Roman"/>
                         </a:rPr>
-                        <a:t>1,305</a:t>
+                        <a:t>13,055,089</a:t>
                       </a:r>
                       <a:br/>
                       <a:r>
@@ -22691,7 +22691,7 @@
                           </a:solidFill>
                           <a:latin typeface="Times New Roman"/>
                         </a:rPr>
-                        <a:t>0.13 Cr</a:t>
+                        <a:t>1305.51 Cr</a:t>
                       </a:r>
                     </a:p>
                   </a:txBody>
@@ -22734,7 +22734,7 @@
                           </a:solidFill>
                           <a:latin typeface="Times New Roman"/>
                         </a:rPr>
-                        <a:t>544</a:t>
+                        <a:t>5,439,620</a:t>
                       </a:r>
                       <a:br/>
                       <a:r>
@@ -22744,7 +22744,7 @@
                           </a:solidFill>
                           <a:latin typeface="Times New Roman"/>
                         </a:rPr>
-                        <a:t>0.05 Cr</a:t>
+                        <a:t>543.96 Cr</a:t>
                       </a:r>
                     </a:p>
                   </a:txBody>
@@ -22840,7 +22840,7 @@
                           </a:solidFill>
                           <a:latin typeface="Times New Roman"/>
                         </a:rPr>
-                        <a:t>7,386,244</a:t>
+                        <a:t>1,947,168</a:t>
                       </a:r>
                       <a:br/>
                       <a:r>
@@ -22850,7 +22850,7 @@
                           </a:solidFill>
                           <a:latin typeface="Times New Roman"/>
                         </a:rPr>
-                        <a:t>738.62 Cr</a:t>
+                        <a:t>194.72 Cr</a:t>
                       </a:r>
                     </a:p>
                   </a:txBody>
@@ -22893,7 +22893,7 @@
                           </a:solidFill>
                           <a:latin typeface="Times New Roman"/>
                         </a:rPr>
-                        <a:t>1358490</a:t>
+                        <a:t>136</a:t>
                       </a:r>
                     </a:p>
                   </a:txBody>
@@ -22936,7 +22936,7 @@
                           </a:solidFill>
                           <a:latin typeface="Times New Roman"/>
                         </a:rPr>
-                        <a:t>-7,385,483</a:t>
+                        <a:t>5,668,301</a:t>
                       </a:r>
                       <a:br/>
                       <a:r>
@@ -22946,7 +22946,7 @@
                           </a:solidFill>
                           <a:latin typeface="Times New Roman"/>
                         </a:rPr>
-                        <a:t>-738.55 Cr</a:t>
+                        <a:t>566.83 Cr</a:t>
                       </a:r>
                     </a:p>
                   </a:txBody>
@@ -22989,33 +22989,33 @@
                           </a:solidFill>
                           <a:latin typeface="Times New Roman"/>
                         </a:rPr>
-                        <a:t>566037</a:t>
-                      </a:r>
-                    </a:p>
-                  </a:txBody>
-                  <a:tcPr marL="12000" marR="12000" marT="8000" marB="8000">
-                    <a:lnL w="12700">
-                      <a:solidFill>
-                        <a:srgbClr val="000000"/>
-                      </a:solidFill>
-                    </a:lnL>
-                    <a:lnR w="12700">
-                      <a:solidFill>
-                        <a:srgbClr val="000000"/>
-                      </a:solidFill>
-                    </a:lnR>
-                    <a:lnT w="12700">
-                      <a:solidFill>
-                        <a:srgbClr val="000000"/>
-                      </a:solidFill>
-                    </a:lnT>
-                    <a:lnB w="12700">
-                      <a:solidFill>
-                        <a:srgbClr val="000000"/>
-                      </a:solidFill>
-                    </a:lnB>
-                    <a:solidFill>
-                      <a:srgbClr val="D92323"/>
+                        <a:t>57</a:t>
+                      </a:r>
+                    </a:p>
+                  </a:txBody>
+                  <a:tcPr marL="12000" marR="12000" marT="8000" marB="8000">
+                    <a:lnL w="12700">
+                      <a:solidFill>
+                        <a:srgbClr val="000000"/>
+                      </a:solidFill>
+                    </a:lnL>
+                    <a:lnR w="12700">
+                      <a:solidFill>
+                        <a:srgbClr val="000000"/>
+                      </a:solidFill>
+                    </a:lnR>
+                    <a:lnT w="12700">
+                      <a:solidFill>
+                        <a:srgbClr val="000000"/>
+                      </a:solidFill>
+                    </a:lnT>
+                    <a:lnB w="12700">
+                      <a:solidFill>
+                        <a:srgbClr val="000000"/>
+                      </a:solidFill>
+                    </a:lnB>
+                    <a:solidFill>
+                      <a:srgbClr val="25A55B"/>
                     </a:solidFill>
                   </a:tcPr>
                 </a:tc>
@@ -23133,7 +23133,7 @@
                 </a:solidFill>
                 <a:latin typeface="Times New Roman"/>
               </a:rPr>
-              <a:t>Open Line FR Report - As On 05.09.2026 (Rows 1-13)</a:t>
+              <a:t>Open Line FR Report - As On 25.09.2026 (Rows 1-13)</a:t>
             </a:r>
           </a:p>
         </p:txBody>
@@ -23677,7 +23677,7 @@
                           </a:solidFill>
                           <a:latin typeface="Times New Roman"/>
                         </a:rPr>
-                        <a:t>77,992</a:t>
+                        <a:t>81,555</a:t>
                       </a:r>
                       <a:br/>
                       <a:r>
@@ -23687,7 +23687,7 @@
                           </a:solidFill>
                           <a:latin typeface="Times New Roman"/>
                         </a:rPr>
-                        <a:t>7.80 Cr</a:t>
+                        <a:t>8.16 Cr</a:t>
                       </a:r>
                     </a:p>
                   </a:txBody>
@@ -23730,7 +23730,7 @@
                           </a:solidFill>
                           <a:latin typeface="Times New Roman"/>
                         </a:rPr>
-                        <a:t>-82,911</a:t>
+                        <a:t>-79,348</a:t>
                       </a:r>
                       <a:br/>
                       <a:r>
@@ -23740,7 +23740,7 @@
                           </a:solidFill>
                           <a:latin typeface="Times New Roman"/>
                         </a:rPr>
-                        <a:t>-8.29 Cr</a:t>
+                        <a:t>-7.93 Cr</a:t>
                       </a:r>
                     </a:p>
                   </a:txBody>
@@ -23783,7 +23783,7 @@
                           </a:solidFill>
                           <a:latin typeface="Times New Roman"/>
                         </a:rPr>
-                        <a:t>48.47</a:t>
+                        <a:t>50.69</a:t>
                       </a:r>
                     </a:p>
                   </a:txBody>
@@ -24010,7 +24010,7 @@
                           </a:solidFill>
                           <a:latin typeface="Times New Roman"/>
                         </a:rPr>
-                        <a:t>11,801</a:t>
+                        <a:t>12,767</a:t>
                       </a:r>
                       <a:br/>
                       <a:r>
@@ -24020,7 +24020,7 @@
                           </a:solidFill>
                           <a:latin typeface="Times New Roman"/>
                         </a:rPr>
-                        <a:t>1.18 Cr</a:t>
+                        <a:t>1.28 Cr</a:t>
                       </a:r>
                     </a:p>
                   </a:txBody>
@@ -24063,7 +24063,7 @@
                           </a:solidFill>
                           <a:latin typeface="Times New Roman"/>
                         </a:rPr>
-                        <a:t>-20,426</a:t>
+                        <a:t>-19,460</a:t>
                       </a:r>
                       <a:br/>
                       <a:r>
@@ -24073,7 +24073,7 @@
                           </a:solidFill>
                           <a:latin typeface="Times New Roman"/>
                         </a:rPr>
-                        <a:t>-2.04 Cr</a:t>
+                        <a:t>-1.95 Cr</a:t>
                       </a:r>
                     </a:p>
                   </a:txBody>
@@ -24116,7 +24116,7 @@
                           </a:solidFill>
                           <a:latin typeface="Times New Roman"/>
                         </a:rPr>
-                        <a:t>36.62</a:t>
+                        <a:t>39.62</a:t>
                       </a:r>
                     </a:p>
                   </a:txBody>
@@ -24343,7 +24343,7 @@
                           </a:solidFill>
                           <a:latin typeface="Times New Roman"/>
                         </a:rPr>
-                        <a:t>57,289</a:t>
+                        <a:t>64,676</a:t>
                       </a:r>
                       <a:br/>
                       <a:r>
@@ -24353,7 +24353,7 @@
                           </a:solidFill>
                           <a:latin typeface="Times New Roman"/>
                         </a:rPr>
-                        <a:t>5.73 Cr</a:t>
+                        <a:t>6.47 Cr</a:t>
                       </a:r>
                     </a:p>
                   </a:txBody>
@@ -24396,7 +24396,7 @@
                           </a:solidFill>
                           <a:latin typeface="Times New Roman"/>
                         </a:rPr>
-                        <a:t>-63,029</a:t>
+                        <a:t>-55,642</a:t>
                       </a:r>
                       <a:br/>
                       <a:r>
@@ -24406,7 +24406,7 @@
                           </a:solidFill>
                           <a:latin typeface="Times New Roman"/>
                         </a:rPr>
-                        <a:t>-6.30 Cr</a:t>
+                        <a:t>-5.56 Cr</a:t>
                       </a:r>
                     </a:p>
                   </a:txBody>
@@ -24449,7 +24449,7 @@
                           </a:solidFill>
                           <a:latin typeface="Times New Roman"/>
                         </a:rPr>
-                        <a:t>47.61</a:t>
+                        <a:t>53.75</a:t>
                       </a:r>
                     </a:p>
                   </a:txBody>
@@ -24676,7 +24676,7 @@
                           </a:solidFill>
                           <a:latin typeface="Times New Roman"/>
                         </a:rPr>
-                        <a:t>363,937</a:t>
+                        <a:t>379,202</a:t>
                       </a:r>
                       <a:br/>
                       <a:r>
@@ -24686,7 +24686,7 @@
                           </a:solidFill>
                           <a:latin typeface="Times New Roman"/>
                         </a:rPr>
-                        <a:t>36.39 Cr</a:t>
+                        <a:t>37.92 Cr</a:t>
                       </a:r>
                     </a:p>
                   </a:txBody>
@@ -24729,7 +24729,7 @@
                           </a:solidFill>
                           <a:latin typeface="Times New Roman"/>
                         </a:rPr>
-                        <a:t>-143,483</a:t>
+                        <a:t>-128,218</a:t>
                       </a:r>
                       <a:br/>
                       <a:r>
@@ -24739,7 +24739,7 @@
                           </a:solidFill>
                           <a:latin typeface="Times New Roman"/>
                         </a:rPr>
-                        <a:t>-14.35 Cr</a:t>
+                        <a:t>-12.82 Cr</a:t>
                       </a:r>
                     </a:p>
                   </a:txBody>
@@ -24782,7 +24782,7 @@
                           </a:solidFill>
                           <a:latin typeface="Times New Roman"/>
                         </a:rPr>
-                        <a:t>71.72</a:t>
+                        <a:t>74.73</a:t>
                       </a:r>
                     </a:p>
                   </a:txBody>
@@ -25009,7 +25009,7 @@
                           </a:solidFill>
                           <a:latin typeface="Times New Roman"/>
                         </a:rPr>
-                        <a:t>3,692,699</a:t>
+                        <a:t>3,805,865</a:t>
                       </a:r>
                       <a:br/>
                       <a:r>
@@ -25019,7 +25019,7 @@
                           </a:solidFill>
                           <a:latin typeface="Times New Roman"/>
                         </a:rPr>
-                        <a:t>369.27 Cr</a:t>
+                        <a:t>380.59 Cr</a:t>
                       </a:r>
                     </a:p>
                   </a:txBody>
@@ -25062,7 +25062,7 @@
                           </a:solidFill>
                           <a:latin typeface="Times New Roman"/>
                         </a:rPr>
-                        <a:t>729,904</a:t>
+                        <a:t>843,070</a:t>
                       </a:r>
                       <a:br/>
                       <a:r>
@@ -25072,7 +25072,7 @@
                           </a:solidFill>
                           <a:latin typeface="Times New Roman"/>
                         </a:rPr>
-                        <a:t>72.99 Cr</a:t>
+                        <a:t>84.31 Cr</a:t>
                       </a:r>
                     </a:p>
                   </a:txBody>
@@ -25115,7 +25115,7 @@
                           </a:solidFill>
                           <a:latin typeface="Times New Roman"/>
                         </a:rPr>
-                        <a:t>124.64</a:t>
+                        <a:t>128.46</a:t>
                       </a:r>
                     </a:p>
                   </a:txBody>
@@ -25342,7 +25342,7 @@
                           </a:solidFill>
                           <a:latin typeface="Times New Roman"/>
                         </a:rPr>
-                        <a:t>151,197</a:t>
+                        <a:t>183,938</a:t>
                       </a:r>
                       <a:br/>
                       <a:r>
@@ -25352,7 +25352,7 @@
                           </a:solidFill>
                           <a:latin typeface="Times New Roman"/>
                         </a:rPr>
-                        <a:t>15.12 Cr</a:t>
+                        <a:t>18.39 Cr</a:t>
                       </a:r>
                     </a:p>
                   </a:txBody>
@@ -25395,7 +25395,7 @@
                           </a:solidFill>
                           <a:latin typeface="Times New Roman"/>
                         </a:rPr>
-                        <a:t>18,930</a:t>
+                        <a:t>51,671</a:t>
                       </a:r>
                       <a:br/>
                       <a:r>
@@ -25405,7 +25405,7 @@
                           </a:solidFill>
                           <a:latin typeface="Times New Roman"/>
                         </a:rPr>
-                        <a:t>1.89 Cr</a:t>
+                        <a:t>5.17 Cr</a:t>
                       </a:r>
                     </a:p>
                   </a:txBody>
@@ -25448,7 +25448,7 @@
                           </a:solidFill>
                           <a:latin typeface="Times New Roman"/>
                         </a:rPr>
-                        <a:t>114.31</a:t>
+                        <a:t>139.07</a:t>
                       </a:r>
                     </a:p>
                   </a:txBody>
@@ -25675,7 +25675,7 @@
                           </a:solidFill>
                           <a:latin typeface="Times New Roman"/>
                         </a:rPr>
-                        <a:t>123,038</a:t>
+                        <a:t>140,407</a:t>
                       </a:r>
                       <a:br/>
                       <a:r>
@@ -25685,7 +25685,7 @@
                           </a:solidFill>
                           <a:latin typeface="Times New Roman"/>
                         </a:rPr>
-                        <a:t>12.30 Cr</a:t>
+                        <a:t>14.04 Cr</a:t>
                       </a:r>
                     </a:p>
                   </a:txBody>
@@ -25728,7 +25728,7 @@
                           </a:solidFill>
                           <a:latin typeface="Times New Roman"/>
                         </a:rPr>
-                        <a:t>-399,805</a:t>
+                        <a:t>-382,436</a:t>
                       </a:r>
                       <a:br/>
                       <a:r>
@@ -25738,7 +25738,7 @@
                           </a:solidFill>
                           <a:latin typeface="Times New Roman"/>
                         </a:rPr>
-                        <a:t>-39.98 Cr</a:t>
+                        <a:t>-38.24 Cr</a:t>
                       </a:r>
                     </a:p>
                   </a:txBody>
@@ -25781,7 +25781,7 @@
                           </a:solidFill>
                           <a:latin typeface="Times New Roman"/>
                         </a:rPr>
-                        <a:t>23.53</a:t>
+                        <a:t>26.85</a:t>
                       </a:r>
                     </a:p>
                   </a:txBody>
@@ -26008,7 +26008,7 @@
                           </a:solidFill>
                           <a:latin typeface="Times New Roman"/>
                         </a:rPr>
-                        <a:t>94,924</a:t>
+                        <a:t>105,095</a:t>
                       </a:r>
                       <a:br/>
                       <a:r>
@@ -26018,7 +26018,7 @@
                           </a:solidFill>
                           <a:latin typeface="Times New Roman"/>
                         </a:rPr>
-                        <a:t>9.49 Cr</a:t>
+                        <a:t>10.51 Cr</a:t>
                       </a:r>
                     </a:p>
                   </a:txBody>
@@ -26061,7 +26061,7 @@
                           </a:solidFill>
                           <a:latin typeface="Times New Roman"/>
                         </a:rPr>
-                        <a:t>-212,919</a:t>
+                        <a:t>-202,748</a:t>
                       </a:r>
                       <a:br/>
                       <a:r>
@@ -26071,7 +26071,7 @@
                           </a:solidFill>
                           <a:latin typeface="Times New Roman"/>
                         </a:rPr>
-                        <a:t>-21.29 Cr</a:t>
+                        <a:t>-20.27 Cr</a:t>
                       </a:r>
                     </a:p>
                   </a:txBody>
@@ -26114,7 +26114,7 @@
                           </a:solidFill>
                           <a:latin typeface="Times New Roman"/>
                         </a:rPr>
-                        <a:t>30.84</a:t>
+                        <a:t>34.14</a:t>
                       </a:r>
                     </a:p>
                   </a:txBody>
@@ -26621,7 +26621,7 @@
                           </a:solidFill>
                           <a:latin typeface="Times New Roman"/>
                         </a:rPr>
-                        <a:t>13,194</a:t>
+                        <a:t>40,372</a:t>
                       </a:r>
                       <a:br/>
                       <a:r>
@@ -26631,7 +26631,7 @@
                           </a:solidFill>
                           <a:latin typeface="Times New Roman"/>
                         </a:rPr>
-                        <a:t>1.32 Cr</a:t>
+                        <a:t>4.04 Cr</a:t>
                       </a:r>
                     </a:p>
                   </a:txBody>
@@ -26674,7 +26674,7 @@
                           </a:solidFill>
                           <a:latin typeface="Times New Roman"/>
                         </a:rPr>
-                        <a:t>24,273</a:t>
+                        <a:t>25,991</a:t>
                       </a:r>
                       <a:br/>
                       <a:r>
@@ -26684,7 +26684,7 @@
                           </a:solidFill>
                           <a:latin typeface="Times New Roman"/>
                         </a:rPr>
-                        <a:t>2.43 Cr</a:t>
+                        <a:t>2.60 Cr</a:t>
                       </a:r>
                     </a:p>
                   </a:txBody>
@@ -26727,7 +26727,7 @@
                           </a:solidFill>
                           <a:latin typeface="Times New Roman"/>
                         </a:rPr>
-                        <a:t>11,079</a:t>
+                        <a:t>-14,381</a:t>
                       </a:r>
                       <a:br/>
                       <a:r>
@@ -26737,7 +26737,7 @@
                           </a:solidFill>
                           <a:latin typeface="Times New Roman"/>
                         </a:rPr>
-                        <a:t>1.11 Cr</a:t>
+                        <a:t>-1.44 Cr</a:t>
                       </a:r>
                     </a:p>
                   </a:txBody>
@@ -26780,33 +26780,33 @@
                           </a:solidFill>
                           <a:latin typeface="Times New Roman"/>
                         </a:rPr>
-                        <a:t>183.97</a:t>
-                      </a:r>
-                    </a:p>
-                  </a:txBody>
-                  <a:tcPr marL="12000" marR="12000" marT="8000" marB="8000">
-                    <a:lnL w="12700">
-                      <a:solidFill>
-                        <a:srgbClr val="000000"/>
-                      </a:solidFill>
-                    </a:lnL>
-                    <a:lnR w="12700">
-                      <a:solidFill>
-                        <a:srgbClr val="000000"/>
-                      </a:solidFill>
-                    </a:lnR>
-                    <a:lnT w="12700">
-                      <a:solidFill>
-                        <a:srgbClr val="000000"/>
-                      </a:solidFill>
-                    </a:lnT>
-                    <a:lnB w="12700">
-                      <a:solidFill>
-                        <a:srgbClr val="000000"/>
-                      </a:solidFill>
-                    </a:lnB>
-                    <a:solidFill>
-                      <a:srgbClr val="FCE4E4"/>
+                        <a:t>64.38</a:t>
+                      </a:r>
+                    </a:p>
+                  </a:txBody>
+                  <a:tcPr marL="12000" marR="12000" marT="8000" marB="8000">
+                    <a:lnL w="12700">
+                      <a:solidFill>
+                        <a:srgbClr val="000000"/>
+                      </a:solidFill>
+                    </a:lnL>
+                    <a:lnR w="12700">
+                      <a:solidFill>
+                        <a:srgbClr val="000000"/>
+                      </a:solidFill>
+                    </a:lnR>
+                    <a:lnT w="12700">
+                      <a:solidFill>
+                        <a:srgbClr val="000000"/>
+                      </a:solidFill>
+                    </a:lnT>
+                    <a:lnB w="12700">
+                      <a:solidFill>
+                        <a:srgbClr val="000000"/>
+                      </a:solidFill>
+                    </a:lnB>
+                    <a:solidFill>
+                      <a:srgbClr val="DFF3E7"/>
                     </a:solidFill>
                   </a:tcPr>
                 </a:tc>
@@ -27007,7 +27007,7 @@
                           </a:solidFill>
                           <a:latin typeface="Times New Roman"/>
                         </a:rPr>
-                        <a:t>5,129</a:t>
+                        <a:t>5,681</a:t>
                       </a:r>
                       <a:br/>
                       <a:r>
@@ -27017,7 +27017,7 @@
                           </a:solidFill>
                           <a:latin typeface="Times New Roman"/>
                         </a:rPr>
-                        <a:t>0.51 Cr</a:t>
+                        <a:t>0.57 Cr</a:t>
                       </a:r>
                     </a:p>
                   </a:txBody>
@@ -27060,7 +27060,7 @@
                           </a:solidFill>
                           <a:latin typeface="Times New Roman"/>
                         </a:rPr>
-                        <a:t>-48,573</a:t>
+                        <a:t>-48,021</a:t>
                       </a:r>
                       <a:br/>
                       <a:r>
@@ -27070,7 +27070,7 @@
                           </a:solidFill>
                           <a:latin typeface="Times New Roman"/>
                         </a:rPr>
-                        <a:t>-4.86 Cr</a:t>
+                        <a:t>-4.80 Cr</a:t>
                       </a:r>
                     </a:p>
                   </a:txBody>
@@ -27113,7 +27113,7 @@
                           </a:solidFill>
                           <a:latin typeface="Times New Roman"/>
                         </a:rPr>
-                        <a:t>9.55</a:t>
+                        <a:t>10.58</a:t>
                       </a:r>
                     </a:p>
                   </a:txBody>
@@ -27340,7 +27340,7 @@
                           </a:solidFill>
                           <a:latin typeface="Times New Roman"/>
                         </a:rPr>
-                        <a:t>59,852</a:t>
+                        <a:t>71,111</a:t>
                       </a:r>
                       <a:br/>
                       <a:r>
@@ -27350,7 +27350,7 @@
                           </a:solidFill>
                           <a:latin typeface="Times New Roman"/>
                         </a:rPr>
-                        <a:t>5.99 Cr</a:t>
+                        <a:t>7.11 Cr</a:t>
                       </a:r>
                     </a:p>
                   </a:txBody>
@@ -27393,7 +27393,7 @@
                           </a:solidFill>
                           <a:latin typeface="Times New Roman"/>
                         </a:rPr>
-                        <a:t>-37,648</a:t>
+                        <a:t>-26,389</a:t>
                       </a:r>
                       <a:br/>
                       <a:r>
@@ -27403,7 +27403,7 @@
                           </a:solidFill>
                           <a:latin typeface="Times New Roman"/>
                         </a:rPr>
-                        <a:t>-3.76 Cr</a:t>
+                        <a:t>-2.64 Cr</a:t>
                       </a:r>
                     </a:p>
                   </a:txBody>
@@ -27446,7 +27446,7 @@
                           </a:solidFill>
                           <a:latin typeface="Times New Roman"/>
                         </a:rPr>
-                        <a:t>61.39</a:t>
+                        <a:t>72.93</a:t>
                       </a:r>
                     </a:p>
                   </a:txBody>
@@ -27673,7 +27673,7 @@
                           </a:solidFill>
                           <a:latin typeface="Times New Roman"/>
                         </a:rPr>
-                        <a:t>131,048</a:t>
+                        <a:t>147,126</a:t>
                       </a:r>
                       <a:br/>
                       <a:r>
@@ -27683,7 +27683,7 @@
                           </a:solidFill>
                           <a:latin typeface="Times New Roman"/>
                         </a:rPr>
-                        <a:t>13.10 Cr</a:t>
+                        <a:t>14.71 Cr</a:t>
                       </a:r>
                     </a:p>
                   </a:txBody>
@@ -27726,7 +27726,7 @@
                           </a:solidFill>
                           <a:latin typeface="Times New Roman"/>
                         </a:rPr>
-                        <a:t>-179,864</a:t>
+                        <a:t>-163,786</a:t>
                       </a:r>
                       <a:br/>
                       <a:r>
@@ -27736,7 +27736,7 @@
                           </a:solidFill>
                           <a:latin typeface="Times New Roman"/>
                         </a:rPr>
-                        <a:t>-17.99 Cr</a:t>
+                        <a:t>-16.38 Cr</a:t>
                       </a:r>
                     </a:p>
                   </a:txBody>
@@ -27779,7 +27779,7 @@
                           </a:solidFill>
                           <a:latin typeface="Times New Roman"/>
                         </a:rPr>
-                        <a:t>42.15</a:t>
+                        <a:t>47.32</a:t>
                       </a:r>
                     </a:p>
                   </a:txBody>
@@ -27913,7 +27913,7 @@
                 </a:solidFill>
                 <a:latin typeface="Times New Roman"/>
               </a:rPr>
-              <a:t>Open Line FR Report - As On 05.09.2026 (Rows 14-18)</a:t>
+              <a:t>Open Line FR Report - As On 25.09.2026 (Rows 14-18)</a:t>
             </a:r>
           </a:p>
         </p:txBody>
@@ -28790,7 +28790,7 @@
                           </a:solidFill>
                           <a:latin typeface="Times New Roman"/>
                         </a:rPr>
-                        <a:t>103,375</a:t>
+                        <a:t>112,585</a:t>
                       </a:r>
                       <a:br/>
                       <a:r>
@@ -28800,7 +28800,7 @@
                           </a:solidFill>
                           <a:latin typeface="Times New Roman"/>
                         </a:rPr>
-                        <a:t>10.34 Cr</a:t>
+                        <a:t>11.26 Cr</a:t>
                       </a:r>
                     </a:p>
                   </a:txBody>
@@ -28843,7 +28843,7 @@
                           </a:solidFill>
                           <a:latin typeface="Times New Roman"/>
                         </a:rPr>
-                        <a:t>-212,358</a:t>
+                        <a:t>-203,148</a:t>
                       </a:r>
                       <a:br/>
                       <a:r>
@@ -28853,7 +28853,7 @@
                           </a:solidFill>
                           <a:latin typeface="Times New Roman"/>
                         </a:rPr>
-                        <a:t>-21.24 Cr</a:t>
+                        <a:t>-20.31 Cr</a:t>
                       </a:r>
                     </a:p>
                   </a:txBody>
@@ -28896,7 +28896,7 @@
                           </a:solidFill>
                           <a:latin typeface="Times New Roman"/>
                         </a:rPr>
-                        <a:t>32.74</a:t>
+                        <a:t>35.66</a:t>
                       </a:r>
                     </a:p>
                   </a:txBody>
@@ -29736,7 +29736,7 @@
                           </a:solidFill>
                           <a:latin typeface="Times New Roman"/>
                         </a:rPr>
-                        <a:t>5,607,701</a:t>
+                        <a:t>5,634,879</a:t>
                       </a:r>
                       <a:br/>
                       <a:r>
@@ -29746,7 +29746,7 @@
                           </a:solidFill>
                           <a:latin typeface="Times New Roman"/>
                         </a:rPr>
-                        <a:t>560.77 Cr</a:t>
+                        <a:t>563.49 Cr</a:t>
                       </a:r>
                     </a:p>
                   </a:txBody>
@@ -29789,7 +29789,7 @@
                           </a:solidFill>
                           <a:latin typeface="Times New Roman"/>
                         </a:rPr>
-                        <a:t>4,896,554</a:t>
+                        <a:t>5,135,999</a:t>
                       </a:r>
                       <a:br/>
                       <a:r>
@@ -29799,7 +29799,7 @@
                           </a:solidFill>
                           <a:latin typeface="Times New Roman"/>
                         </a:rPr>
-                        <a:t>489.66 Cr</a:t>
+                        <a:t>513.60 Cr</a:t>
                       </a:r>
                     </a:p>
                   </a:txBody>
@@ -29842,7 +29842,7 @@
                           </a:solidFill>
                           <a:latin typeface="Times New Roman"/>
                         </a:rPr>
-                        <a:t>-711,147</a:t>
+                        <a:t>-498,880</a:t>
                       </a:r>
                       <a:br/>
                       <a:r>
@@ -29852,7 +29852,7 @@
                           </a:solidFill>
                           <a:latin typeface="Times New Roman"/>
                         </a:rPr>
-                        <a:t>-71.11 Cr</a:t>
+                        <a:t>-49.89 Cr</a:t>
                       </a:r>
                     </a:p>
                   </a:txBody>
@@ -29895,7 +29895,7 @@
                           </a:solidFill>
                           <a:latin typeface="Times New Roman"/>
                         </a:rPr>
-                        <a:t>87.32</a:t>
+                        <a:t>91.15</a:t>
                       </a:r>
                     </a:p>
                   </a:txBody>
@@ -30029,7 +30029,7 @@
                 </a:solidFill>
                 <a:latin typeface="Times New Roman"/>
               </a:rPr>
-              <a:t>Open Line FR Fund Wise - As On 05.09.2026</a:t>
+              <a:t>Open Line FR Fund Wise - As On 25.09.2026</a:t>
             </a:r>
           </a:p>
         </p:txBody>
@@ -30477,7 +30477,7 @@
                           </a:solidFill>
                           <a:latin typeface="Times New Roman"/>
                         </a:rPr>
-                        <a:t>1,018,353</a:t>
+                        <a:t>1,045,531</a:t>
                       </a:r>
                       <a:br/>
                       <a:r>
@@ -30487,7 +30487,7 @@
                           </a:solidFill>
                           <a:latin typeface="Times New Roman"/>
                         </a:rPr>
-                        <a:t>101.84 Cr</a:t>
+                        <a:t>104.55 Cr</a:t>
                       </a:r>
                     </a:p>
                   </a:txBody>
@@ -30530,7 +30530,7 @@
                           </a:solidFill>
                           <a:latin typeface="Times New Roman"/>
                         </a:rPr>
-                        <a:t>408,842</a:t>
+                        <a:t>457,028</a:t>
                       </a:r>
                       <a:br/>
                       <a:r>
@@ -30540,7 +30540,7 @@
                           </a:solidFill>
                           <a:latin typeface="Times New Roman"/>
                         </a:rPr>
-                        <a:t>40.88 Cr</a:t>
+                        <a:t>45.70 Cr</a:t>
                       </a:r>
                     </a:p>
                   </a:txBody>
@@ -30583,7 +30583,7 @@
                           </a:solidFill>
                           <a:latin typeface="Times New Roman"/>
                         </a:rPr>
-                        <a:t>609,511</a:t>
+                        <a:t>588,503</a:t>
                       </a:r>
                       <a:br/>
                       <a:r>
@@ -30593,7 +30593,7 @@
                           </a:solidFill>
                           <a:latin typeface="Times New Roman"/>
                         </a:rPr>
-                        <a:t>60.95 Cr</a:t>
+                        <a:t>58.85 Cr</a:t>
                       </a:r>
                     </a:p>
                   </a:txBody>
@@ -30636,7 +30636,7 @@
                           </a:solidFill>
                           <a:latin typeface="Times New Roman"/>
                         </a:rPr>
-                        <a:t>40.15</a:t>
+                        <a:t>43.71</a:t>
                       </a:r>
                     </a:p>
                   </a:txBody>
@@ -30679,7 +30679,7 @@
                           </a:solidFill>
                           <a:latin typeface="Times New Roman"/>
                         </a:rPr>
-                        <a:t>59.85</a:t>
+                        <a:t>56.29</a:t>
                       </a:r>
                     </a:p>
                   </a:txBody>
@@ -30863,7 +30863,7 @@
                           </a:solidFill>
                           <a:latin typeface="Times New Roman"/>
                         </a:rPr>
-                        <a:t>15,491</a:t>
+                        <a:t>21,238</a:t>
                       </a:r>
                       <a:br/>
                       <a:r>
@@ -30873,7 +30873,7 @@
                           </a:solidFill>
                           <a:latin typeface="Times New Roman"/>
                         </a:rPr>
-                        <a:t>1.55 Cr</a:t>
+                        <a:t>2.12 Cr</a:t>
                       </a:r>
                     </a:p>
                   </a:txBody>
@@ -30916,7 +30916,7 @@
                           </a:solidFill>
                           <a:latin typeface="Times New Roman"/>
                         </a:rPr>
-                        <a:t>24,741</a:t>
+                        <a:t>18,994</a:t>
                       </a:r>
                       <a:br/>
                       <a:r>
@@ -30926,7 +30926,7 @@
                           </a:solidFill>
                           <a:latin typeface="Times New Roman"/>
                         </a:rPr>
-                        <a:t>2.47 Cr</a:t>
+                        <a:t>1.90 Cr</a:t>
                       </a:r>
                     </a:p>
                   </a:txBody>
@@ -30969,7 +30969,7 @@
                           </a:solidFill>
                           <a:latin typeface="Times New Roman"/>
                         </a:rPr>
-                        <a:t>38.50</a:t>
+                        <a:t>52.79</a:t>
                       </a:r>
                     </a:p>
                   </a:txBody>
@@ -31012,7 +31012,7 @@
                           </a:solidFill>
                           <a:latin typeface="Times New Roman"/>
                         </a:rPr>
-                        <a:t>61.50</a:t>
+                        <a:t>47.21</a:t>
                       </a:r>
                     </a:p>
                   </a:txBody>
@@ -31862,7 +31862,7 @@
                           </a:solidFill>
                           <a:latin typeface="Times New Roman"/>
                         </a:rPr>
-                        <a:t>3,746,106</a:t>
+                        <a:t>3,844,908</a:t>
                       </a:r>
                       <a:br/>
                       <a:r>
@@ -31872,7 +31872,7 @@
                           </a:solidFill>
                           <a:latin typeface="Times New Roman"/>
                         </a:rPr>
-                        <a:t>374.61 Cr</a:t>
+                        <a:t>384.49 Cr</a:t>
                       </a:r>
                     </a:p>
                   </a:txBody>
@@ -31915,7 +31915,7 @@
                           </a:solidFill>
                           <a:latin typeface="Times New Roman"/>
                         </a:rPr>
-                        <a:t>-628,591</a:t>
+                        <a:t>-727,393</a:t>
                       </a:r>
                       <a:br/>
                       <a:r>
@@ -31925,7 +31925,7 @@
                           </a:solidFill>
                           <a:latin typeface="Times New Roman"/>
                         </a:rPr>
-                        <a:t>-62.86 Cr</a:t>
+                        <a:t>-72.74 Cr</a:t>
                       </a:r>
                     </a:p>
                   </a:txBody>
@@ -31968,7 +31968,7 @@
                           </a:solidFill>
                           <a:latin typeface="Times New Roman"/>
                         </a:rPr>
-                        <a:t>120.16</a:t>
+                        <a:t>123.33</a:t>
                       </a:r>
                     </a:p>
                   </a:txBody>
@@ -32011,7 +32011,7 @@
                           </a:solidFill>
                           <a:latin typeface="Times New Roman"/>
                         </a:rPr>
-                        <a:t>-20.16</a:t>
+                        <a:t>-23.33</a:t>
                       </a:r>
                     </a:p>
                   </a:txBody>
@@ -32528,7 +32528,7 @@
                           </a:solidFill>
                           <a:latin typeface="Times New Roman"/>
                         </a:rPr>
-                        <a:t>707,656</a:t>
+                        <a:t>794,366</a:t>
                       </a:r>
                       <a:br/>
                       <a:r>
@@ -32538,7 +32538,7 @@
                           </a:solidFill>
                           <a:latin typeface="Times New Roman"/>
                         </a:rPr>
-                        <a:t>70.77 Cr</a:t>
+                        <a:t>79.44 Cr</a:t>
                       </a:r>
                     </a:p>
                   </a:txBody>
@@ -32581,7 +32581,7 @@
                           </a:solidFill>
                           <a:latin typeface="Times New Roman"/>
                         </a:rPr>
-                        <a:t>593,353</a:t>
+                        <a:t>506,643</a:t>
                       </a:r>
                       <a:br/>
                       <a:r>
@@ -32591,7 +32591,7 @@
                           </a:solidFill>
                           <a:latin typeface="Times New Roman"/>
                         </a:rPr>
-                        <a:t>59.34 Cr</a:t>
+                        <a:t>50.66 Cr</a:t>
                       </a:r>
                     </a:p>
                   </a:txBody>
@@ -32634,7 +32634,7 @@
                           </a:solidFill>
                           <a:latin typeface="Times New Roman"/>
                         </a:rPr>
-                        <a:t>54.39</a:t>
+                        <a:t>61.06</a:t>
                       </a:r>
                     </a:p>
                   </a:txBody>
@@ -32677,7 +32677,7 @@
                           </a:solidFill>
                           <a:latin typeface="Times New Roman"/>
                         </a:rPr>
-                        <a:t>45.61</a:t>
+                        <a:t>38.94</a:t>
                       </a:r>
                     </a:p>
                   </a:txBody>

</xml_diff>

<commit_message>
Harden local sync refresh and rebuild master exports
</commit_message>
<xml_diff>
--- a/exports/Moradabad_Division_DRM_Budget_FR_Analysis.pptx
+++ b/exports/Moradabad_Division_DRM_Budget_FR_Analysis.pptx
@@ -6251,10 +6251,10 @@
                 <a:gridCol w="1118625"/>
                 <a:gridCol w="1118625"/>
                 <a:gridCol w="1222201"/>
-                <a:gridCol w="745749"/>
+                <a:gridCol w="745750"/>
                 <a:gridCol w="1222201"/>
-                <a:gridCol w="745749"/>
-                <a:gridCol w="1118629"/>
+                <a:gridCol w="745750"/>
+                <a:gridCol w="1118627"/>
               </a:tblGrid>
               <a:tr h="432714">
                 <a:tc>

</xml_diff>